<commit_message>
Reframe problem slide diplomatically: manual should-costing to AI-assisted
Slide 4 now positions CostVision as automating the existing, trusted internal
should-cost method rather than criticising it: the current tool is 'capable but
hands-on' (manual input selection, geometry keyed from CAD/drawings), and
CostVision keeps the same rigour while automating those steps with AI. Threads
the same 'automation & AI over a proven method' narrative through the
background, agenda and speaker notes.

Co-Authored-By: Claude Opus 4.8 <noreply@anthropic.com>
Claude-Session: https://claude.ai/code/session_0142L4rKS2AV8rxQTDWMs7dy
</commit_message>
<xml_diff>
--- a/CostVision-Platform-Executive-Briefing.pptx
+++ b/CostVision-Platform-Executive-Briefing.pptx
@@ -1684,7 +1684,7 @@
           <a:p>
             <a:r>
               <a:rPr lang="en-US" dirty="0"/>
-              <a:t>Welcome, and thank you for the time. What you're about to see is CostVision — our own AI cost-intelligence platform. In one sentence: it turns an engineering input — a CAD model, a photo of a circuit board, even a plain-English description — into a defensible, auditable should-cost, in minutes rather than weeks. And unlike a spreadsheet, it learns from every real quote we feed it. Today I'll walk the whole platform, go deep on CAD-to-Cost, show the AI under the hood, and finish with how we'd roll it out and keep the data secure. Everything I show is from live runs — no mock-ups.</a:t>
+              <a:t>Welcome, and thank you for the time. What you're about to see is CostVision — our own AI cost-intelligence platform. Here's the one-line framing for today: we already do rigorous should-costing across every commodity — CostVision takes that same trusted method and automates the manual work with AI. Instead of selecting every input and keying geometry off the CAD and drawings by hand, it reads the model, suggests material and process for you to confirm, and returns a defensible, auditable should-cost in minutes. And unlike a static tool, it learns from every real quote. Today I'll walk the whole platform, go deep on CAD-to-Cost — where the automation is most visible — show the AI under the hood, and finish with how we'd roll it out alongside what we have and keep the data secure. Everything I show is from live runs — no mock-ups.</a:t>
             </a:r>
             <a:endParaRPr lang="en-US" dirty="0"/>
           </a:p>
@@ -2652,7 +2652,7 @@
           <a:p>
             <a:r>
               <a:rPr lang="en-US" dirty="0"/>
-              <a:t>Before we dive in, here's the entire story on one page — if you only take away this slide, you'll have the gist. Five numbers up top: it costs a part in minutes not weeks; it ships nineteen commodity engines and twenty real-rate regions; in a live test it landed within about five percent of a manual estimate; and the autonomous agent found half a million pounds a year with nobody at the keyboard. Underneath: what it actually is — one platform that costs any input, prices it globally, hands you the negotiation, and learns as it goes. The four boxes are the four jobs it does. And the bottom line for this room: faster quotes, better margins, one consistent number, and an intelligence asset that's ours and compounds. Everything after this is detail and proof.</a:t>
+              <a:t>Before we dive in, here's the entire story on one page — if you only take away this slide, you'll have the gist. Keep the framing in mind: this is our proven should-cost method, automated and made intelligent. Five numbers up top: it costs a part in minutes, not the hours of manual setup we spend today; it carries nineteen commodity engines and twenty real-rate regions; in a live test it landed within about five percent of a hand-built estimate; and the autonomous agent found half a million pounds a year with nobody at the keyboard. Underneath: what it is — one platform that reads any input, prices it globally, hands you the negotiation, and learns as it goes. The four boxes are the four jobs it does. And the bottom line for this room: faster quotes, better margins, one consistent number, and an intelligence asset that's ours and compounds. Everything after this is detail and proof.</a:t>
             </a:r>
             <a:endParaRPr lang="en-US" dirty="0"/>
           </a:p>
@@ -2740,7 +2740,7 @@
           <a:p>
             <a:r>
               <a:rPr lang="en-US" dirty="0"/>
-              <a:t>Let me translate all of that into business language — four points. Speed: weeks of RFQ cycle collapse into minutes, so the first defensible number is on the table while the meeting is still happening. Margin: line-level should-cost lets you challenge every quote by driver — and remember, the agent alone surfaced around half a million pounds a year in a demo, unattended. Consistency and speed-to-competence: one answer for everyone, and juniors costing like seniors from day one. And the strategic one — a compounding asset: this becomes proprietary costing intelligence on our own servers. It grows with use, and a competitor can buy the same software but never our accumulated data. Net: faster quotes, better margins, consistent numbers, an asset that appreciates — at no extra licence cost, on our own infrastructure.</a:t>
+              <a:t>Let me translate all of that into business language — four points, and notice they're all about doing what we already do, better and faster. Speed: the hours of manual setup per part collapse into minutes, so the first defensible number is on the table while the meeting is still happening — and our engineers are freed from data entry to spend time on judgement. Margin: line-level should-cost lets us challenge every quote by driver — and the agent alone surfaced around half a million pounds a year in a demo, unattended. Consistency and speed-to-competence: one answer for everyone, and a junior costs like a senior from day one because the method and the memory are shared. And the strategic one — a compounding asset: this becomes proprietary costing intelligence on our own servers. It grows with use, and a competitor can buy software but never our accumulated data. Net: faster quotes, better margins, consistent numbers, and our experts focused on decisions — at no extra licence cost, on our own infrastructure.</a:t>
             </a:r>
             <a:endParaRPr lang="en-US" dirty="0"/>
           </a:p>
@@ -2828,7 +2828,7 @@
           <a:p>
             <a:r>
               <a:rPr lang="en-US" dirty="0"/>
-              <a:t>So how do we get from a demo to business-as-usual? A staged, low-risk blueprint. Phase one, the pilot — six weeks: stand it up on-premise, seed the memory with our historic quotes, cost twenty or thirty live parts, and baseline the accuracy against real actuals so we prove it on our own data. Phase two, scale — roll it out to costing and sourcing, make 'Log Actual £' a routine habit, wire it into the RFQ workflow, and review the agent's findings monthly. Phase three, embed — negotiation packs become standard, portfolio what-if and risk go live, we connect real market feeds, and we track the KPI that matters: pounds saved and cycle-time cut. And I'll be honest about the one dependency: the intelligence starts empty and grows with use — which is exactly why Phase one seeds it, so it starts smart, not from zero.</a:t>
+              <a:t>So how do we get from a demo to business-as-usual? A staged, low-risk blueprint — and importantly, it runs alongside our current tool, not instead of it, until we're confident. Phase one, the pilot — six weeks: stand it up on-premise, seed the memory with our historic quotes, cost twenty or thirty live parts, and baseline the accuracy against both our current method and real actuals so we prove it on our own data. Phase two, scale — roll it out to costing and sourcing, make 'Log Actual £' a routine habit, wire it into the RFQ workflow, and review the agent's findings monthly. Phase three, embed — negotiation packs become standard, portfolio what-if and risk go live, we connect real market feeds, and we track the KPI that matters: pounds saved and cycle-time cut. And I'll be honest about the one dependency: the intelligence starts empty and grows with use — which is exactly why Phase one seeds it, so it starts smart, not from zero.</a:t>
             </a:r>
             <a:endParaRPr lang="en-US" dirty="0"/>
           </a:p>
@@ -3180,7 +3180,7 @@
           <a:p>
             <a:r>
               <a:rPr lang="en-US" dirty="0"/>
-              <a:t>Here's the shape of the next thirty minutes, and a one-paragraph 'why' before we dive in. The problem we all live with: costing is slow, it depends on who does it, and it's inconsistent — and the expertise walks out the door when a senior engineer retires. CostVision is our answer to that. I'll start with the problem in a bit more depth, then give you the whole platform on one slide. Then we go deep where it matters most — CAD-to-Cost — before touring the other capabilities, and I'll close on trust, security, and exactly how we'd roll this out. Feel free to hold questions to the end, or jump in — whichever you prefer.</a:t>
+              <a:t>Here's the shape of the next thirty minutes, and a one-paragraph 'why' before we dive in. Let me set the framing carefully, because it matters: we already do proper should-costing. We have an internal tool that covers every commodity with a rigorous, bottom-up method — that's a real asset and it works. The one thing it asks of us is a lot of manual effort: selecting every input and reading the geometry off the CAD and drawings by hand, part by part. So this isn't a story about a broken system — it's about taking that same trusted method and automating the hands-on parts with AI. I'll start there, then give you the whole platform on one slide, go deep on CAD-to-Cost where the automation is most visible, tour the other capabilities, and close on trust, security and how we'd roll it out alongside what we have today. Jump in any time.</a:t>
             </a:r>
             <a:endParaRPr lang="en-US" dirty="0"/>
           </a:p>
@@ -3268,7 +3268,7 @@
           <a:p>
             <a:r>
               <a:rPr lang="en-US" dirty="0"/>
-              <a:t>Let's name the pain, because everyone in this room has felt it. Today, getting a defensible cost means a two-to-six week RFQ cycle, and what comes back is a single number with no breakdown — so when you want to challenge it, you can't. Worse, the answer depends on who did the estimate; two engineers give you two numbers. And the deepest problem of all: that expertise lives in people's heads and leaves when they do. CostVision flips all four. Minutes not weeks. A full breakdown you can interrogate. One consistent answer from a deterministic engine. And knowledge that compounds instead of evaporating. That's the shift — and everything that follows is how we deliver it.</a:t>
+              <a:t>I want to be clear up front: we're not fixing something broken. Our internal should-cost tool is genuinely good — it's thorough, it's bottom-up, and it covers every commodity. The team has built real rigour into it. The honest observation is simply that it's hands-on: for every part you select the material, the process, the machine, and you key in the geometry and tolerances by hand from the 3D CAD and the drawings — the classic should-costing method. And when economics move, someone updates the rates manually. CostVision doesn't throw any of that away. It keeps the exact same defensible method — and automates the hands-on parts with AI: it reads the CAD and the drawings for you, it suggests the material and process with a confidence score you confirm, and it keeps the rates current on its own. So the shift isn't 'old versus new' — it's the same trusted should-cost, with the manual effort taken out, so our experts spend their time on judgement and decisions instead of data entry. That's the whole story of this deck.</a:t>
             </a:r>
             <a:endParaRPr lang="en-US" dirty="0"/>
           </a:p>
@@ -3532,7 +3532,7 @@
           <a:p>
             <a:r>
               <a:rPr lang="en-US" dirty="0"/>
-              <a:t>Now the heart of the demo — CAD-to-Cost. The promise is simple: drop in a 3D model, get a should-cost. But how it does that is what earns trust. Four moves, left to right. First, it reads the REAL geometry — we run a genuine geometry kernel that measures volume, bounding box and surface area. That's measured ground truth, not the AI guessing. Second, it recognises the manufacturing features — the holes, pockets, slots, bends — and turns them into actual machining operations. Third, the AI proposes a material and a process route, each with a confidence score, and you can override. Fourth, a deterministic engine prices it and explains the number with a confidence band and design-for-manufacture guidance. And note the bottom line — it takes standard CAD formats, no BOM or drawings required. The model IS the input.</a:t>
+              <a:t>Now the heart of the demo — CAD-to-Cost — and this is exactly where the manual effort lives today. In our current method, an engineer opens the CAD, measures it, reads the tolerances off the drawing, and keys all of that in before selecting a process. CostVision does those steps for you. The promise is simple: drop in a 3D model, get a should-cost. But how it does that is what earns trust. Four moves, left to right. First, it reads the REAL geometry — we run a genuine geometry kernel that measures volume, bounding box and surface area. That's measured ground truth, not the AI guessing. Second, it recognises the manufacturing features — the holes, pockets, slots, bends — and turns them into actual machining operations. Third, the AI proposes a material and a process route, each with a confidence score, and you can override. Fourth, a deterministic engine prices it and explains the number with a confidence band and design-for-manufacture guidance. And note the bottom line — it takes standard CAD formats, no BOM or drawings required. The model IS the input.</a:t>
             </a:r>
             <a:endParaRPr lang="en-US" dirty="0"/>
           </a:p>
@@ -32266,12 +32266,12 @@
           <a:p>
             <a:pPr indent="0" marL="0">
               <a:lnSpc>
-                <a:spcPct val="122000"/>
+                <a:spcPct val="116000"/>
               </a:lnSpc>
               <a:buNone/>
             </a:pPr>
             <a:r>
-              <a:rPr lang="en-US" sz="1250" b="1" dirty="0">
+              <a:rPr lang="en-US" sz="1200" b="1" dirty="0">
                 <a:solidFill>
                   <a:srgbClr val="0F1E3D"/>
                 </a:solidFill>
@@ -32283,12 +32283,12 @@
             </a:r>
             <a:pPr indent="0" marL="0">
               <a:lnSpc>
-                <a:spcPct val="122000"/>
+                <a:spcPct val="116000"/>
               </a:lnSpc>
               <a:buNone/>
             </a:pPr>
             <a:r>
-              <a:rPr lang="en-US" sz="1250" dirty="0">
+              <a:rPr lang="en-US" sz="1200" dirty="0">
                 <a:solidFill>
                   <a:srgbClr val="3E4C63"/>
                 </a:solidFill>
@@ -32296,9 +32296,9 @@
                 <a:ea typeface="Calibri" pitchFamily="34" charset="-122"/>
                 <a:cs typeface="Calibri" pitchFamily="34" charset="-120"/>
               </a:rPr>
-              <a:t>cost estimating today is slow, expert-dependent and inconsistent — quotes take weeks, there is no line-of-sight into what a part should cost, and hard-won judgement leaves when people do. CostVision is our answer: one AI platform that costs any part from any input, explains every number, and turns should-cost into negotiating power — while the knowledge compounds as a company asset.</a:t>
-            </a:r>
-            <a:endParaRPr lang="en-US" sz="1250" dirty="0"/>
+              <a:t>we already run rigorous should-costing across every commodity with our internal tool — a proven, bottom-up method. Today it is hands-on: every input is selected and keyed in by hand from the 3D CAD and drawings. CostVision is the next step — it keeps that trusted method and automates the manual work with an AI layer: reading the CAD, suggesting material &amp; process, and keeping rates current. Same defensible number, in minutes — and the knowledge compounds as a company asset.</a:t>
+            </a:r>
+            <a:endParaRPr lang="en-US" sz="1200" dirty="0"/>
           </a:p>
         </p:txBody>
       </p:sp>
@@ -32344,7 +32344,7 @@
             <a:avLst/>
           </a:prstGeom>
           <a:solidFill>
-            <a:srgbClr val="E5484D"/>
+            <a:srgbClr val="2563EB"/>
           </a:solidFill>
           <a:ln/>
           <a:effectLst>
@@ -32428,7 +32428,7 @@
                 <a:ea typeface="Calibri" pitchFamily="34" charset="-122"/>
                 <a:cs typeface="Calibri" pitchFamily="34" charset="-120"/>
               </a:rPr>
-              <a:t>Why CostVision — the problem today</a:t>
+              <a:t>From manual should-costing to AI-assisted</a:t>
             </a:r>
             <a:endParaRPr lang="en-US" sz="1250" dirty="0"/>
           </a:p>
@@ -33748,7 +33748,7 @@
             <a:avLst/>
           </a:prstGeom>
           <a:solidFill>
-            <a:srgbClr val="E5484D"/>
+            <a:srgbClr val="2563EB"/>
           </a:solidFill>
           <a:ln/>
         </p:spPr>
@@ -33780,13 +33780,13 @@
             <a:r>
               <a:rPr lang="en-US" sz="1100" b="1" spc="120" kern="0" dirty="0">
                 <a:solidFill>
-                  <a:srgbClr val="E5484D"/>
-                </a:solidFill>
-                <a:latin typeface="Calibri" pitchFamily="34" charset="0"/>
-                <a:ea typeface="Calibri" pitchFamily="34" charset="-122"/>
-                <a:cs typeface="Calibri" pitchFamily="34" charset="-120"/>
-              </a:rPr>
-              <a:t>THE OPPORTUNITY</a:t>
+                  <a:srgbClr val="2563EB"/>
+                </a:solidFill>
+                <a:latin typeface="Calibri" pitchFamily="34" charset="0"/>
+                <a:ea typeface="Calibri" pitchFamily="34" charset="-122"/>
+                <a:cs typeface="Calibri" pitchFamily="34" charset="-120"/>
+              </a:rPr>
+              <a:t>WHERE WE ARE → WHERE WE GO</a:t>
             </a:r>
             <a:endParaRPr lang="en-US" sz="1100" dirty="0"/>
           </a:p>
@@ -33825,7 +33825,7 @@
                 <a:ea typeface="Calibri" pitchFamily="34" charset="-122"/>
                 <a:cs typeface="Calibri" pitchFamily="34" charset="-120"/>
               </a:rPr>
-              <a:t>Why CostVision — the problem today</a:t>
+              <a:t>From manual should-costing to AI-assisted</a:t>
             </a:r>
             <a:endParaRPr lang="en-US" sz="2400" dirty="0"/>
           </a:p>
@@ -33846,25 +33846,64 @@
             <a:avLst/>
           </a:prstGeom>
           <a:solidFill>
-            <a:srgbClr val="E5484D"/>
-          </a:solidFill>
-          <a:ln/>
-        </p:spPr>
-      </p:sp>
-      <p:sp>
-        <p:nvSpPr>
-          <p:cNvPr id="10" name="Shape 8"/>
-          <p:cNvSpPr/>
-          <p:nvPr/>
-        </p:nvSpPr>
-        <p:spPr>
-          <a:xfrm>
-            <a:off x="548640" y="1600200"/>
-            <a:ext cx="5349240" cy="3657600"/>
+            <a:srgbClr val="2563EB"/>
+          </a:solidFill>
+          <a:ln/>
+        </p:spPr>
+      </p:sp>
+      <p:sp>
+        <p:nvSpPr>
+          <p:cNvPr id="10" name="Text 8"/>
+          <p:cNvSpPr/>
+          <p:nvPr/>
+        </p:nvSpPr>
+        <p:spPr>
+          <a:xfrm>
+            <a:off x="548640" y="1536192"/>
+            <a:ext cx="11064240" cy="365760"/>
+          </a:xfrm>
+          <a:prstGeom prst="rect">
+            <a:avLst/>
+          </a:prstGeom>
+          <a:noFill/>
+          <a:ln/>
+        </p:spPr>
+        <p:txBody>
+          <a:bodyPr wrap="square" lIns="0" tIns="0" rIns="0" bIns="0" rtlCol="0" anchor="t"/>
+          <a:lstStyle/>
+          <a:p>
+            <a:pPr indent="0" marL="0">
+              <a:buNone/>
+            </a:pPr>
+            <a:r>
+              <a:rPr lang="en-US" sz="1200" dirty="0">
+                <a:solidFill>
+                  <a:srgbClr val="3E4C63"/>
+                </a:solidFill>
+                <a:latin typeface="Calibri" pitchFamily="34" charset="0"/>
+                <a:ea typeface="Calibri" pitchFamily="34" charset="-122"/>
+                <a:cs typeface="Calibri" pitchFamily="34" charset="-120"/>
+              </a:rPr>
+              <a:t>We already do rigorous should-costing across every commodity. CostVision keeps that method — and automates the hands-on steps with AI.</a:t>
+            </a:r>
+            <a:endParaRPr lang="en-US" sz="1200" dirty="0"/>
+          </a:p>
+        </p:txBody>
+      </p:sp>
+      <p:sp>
+        <p:nvSpPr>
+          <p:cNvPr id="11" name="Shape 9"/>
+          <p:cNvSpPr/>
+          <p:nvPr/>
+        </p:nvSpPr>
+        <p:spPr>
+          <a:xfrm>
+            <a:off x="548640" y="2057400"/>
+            <a:ext cx="5349240" cy="3246120"/>
           </a:xfrm>
           <a:prstGeom prst="roundRect">
             <a:avLst>
-              <a:gd name="adj" fmla="val 1750"/>
+              <a:gd name="adj" fmla="val 1972"/>
             </a:avLst>
           </a:prstGeom>
           <a:solidFill>
@@ -33880,33 +33919,33 @@
       </p:sp>
       <p:sp>
         <p:nvSpPr>
-          <p:cNvPr id="11" name="Shape 9"/>
-          <p:cNvSpPr/>
-          <p:nvPr/>
-        </p:nvSpPr>
-        <p:spPr>
-          <a:xfrm>
-            <a:off x="548640" y="1600200"/>
+          <p:cNvPr id="12" name="Shape 10"/>
+          <p:cNvSpPr/>
+          <p:nvPr/>
+        </p:nvSpPr>
+        <p:spPr>
+          <a:xfrm>
+            <a:off x="548640" y="2057400"/>
             <a:ext cx="5349240" cy="457200"/>
           </a:xfrm>
           <a:prstGeom prst="rect">
             <a:avLst/>
           </a:prstGeom>
           <a:solidFill>
-            <a:srgbClr val="FDECEC"/>
-          </a:solidFill>
-          <a:ln/>
-        </p:spPr>
-      </p:sp>
-      <p:sp>
-        <p:nvSpPr>
-          <p:cNvPr id="12" name="Text 10"/>
-          <p:cNvSpPr/>
-          <p:nvPr/>
-        </p:nvSpPr>
-        <p:spPr>
-          <a:xfrm>
-            <a:off x="822960" y="1600200"/>
+            <a:srgbClr val="FEF6E7"/>
+          </a:solidFill>
+          <a:ln/>
+        </p:spPr>
+      </p:sp>
+      <p:sp>
+        <p:nvSpPr>
+          <p:cNvPr id="13" name="Text 11"/>
+          <p:cNvSpPr/>
+          <p:nvPr/>
+        </p:nvSpPr>
+        <p:spPr>
+          <a:xfrm>
+            <a:off x="822960" y="2057400"/>
             <a:ext cx="4892040" cy="457200"/>
           </a:xfrm>
           <a:prstGeom prst="rect">
@@ -33925,13 +33964,13 @@
             <a:r>
               <a:rPr lang="en-US" sz="1300" b="1" dirty="0">
                 <a:solidFill>
-                  <a:srgbClr val="E5484D"/>
-                </a:solidFill>
-                <a:latin typeface="Calibri" pitchFamily="34" charset="0"/>
-                <a:ea typeface="Calibri" pitchFamily="34" charset="-122"/>
-                <a:cs typeface="Calibri" pitchFamily="34" charset="-120"/>
-              </a:rPr>
-              <a:t>TODAY</a:t>
+                  <a:srgbClr val="E0900C"/>
+                </a:solidFill>
+                <a:latin typeface="Calibri" pitchFamily="34" charset="0"/>
+                <a:ea typeface="Calibri" pitchFamily="34" charset="-122"/>
+                <a:cs typeface="Calibri" pitchFamily="34" charset="-120"/>
+              </a:rPr>
+              <a:t>OUR SHOULD-COST TODAY  ·  capable, but hands-on</a:t>
             </a:r>
             <a:endParaRPr lang="en-US" sz="1300" dirty="0"/>
           </a:p>
@@ -33939,33 +33978,33 @@
       </p:sp>
       <p:sp>
         <p:nvSpPr>
-          <p:cNvPr id="13" name="Shape 11"/>
-          <p:cNvSpPr/>
-          <p:nvPr/>
-        </p:nvSpPr>
-        <p:spPr>
-          <a:xfrm>
-            <a:off x="804672" y="2240280"/>
+          <p:cNvPr id="14" name="Shape 12"/>
+          <p:cNvSpPr/>
+          <p:nvPr/>
+        </p:nvSpPr>
+        <p:spPr>
+          <a:xfrm>
+            <a:off x="804672" y="2679192"/>
             <a:ext cx="329184" cy="329184"/>
           </a:xfrm>
           <a:prstGeom prst="ellipse">
             <a:avLst/>
           </a:prstGeom>
           <a:solidFill>
-            <a:srgbClr val="FDECEC"/>
-          </a:solidFill>
-          <a:ln/>
-        </p:spPr>
-      </p:sp>
-      <p:sp>
-        <p:nvSpPr>
-          <p:cNvPr id="14" name="Text 12"/>
-          <p:cNvSpPr/>
-          <p:nvPr/>
-        </p:nvSpPr>
-        <p:spPr>
-          <a:xfrm>
-            <a:off x="804672" y="2231136"/>
+            <a:srgbClr val="FEF6E7"/>
+          </a:solidFill>
+          <a:ln/>
+        </p:spPr>
+      </p:sp>
+      <p:sp>
+        <p:nvSpPr>
+          <p:cNvPr id="15" name="Text 13"/>
+          <p:cNvSpPr/>
+          <p:nvPr/>
+        </p:nvSpPr>
+        <p:spPr>
+          <a:xfrm>
+            <a:off x="804672" y="2670048"/>
             <a:ext cx="329184" cy="329184"/>
           </a:xfrm>
           <a:prstGeom prst="rect">
@@ -33982,29 +34021,29 @@
               <a:buNone/>
             </a:pPr>
             <a:r>
-              <a:rPr lang="en-US" sz="1300" b="1" dirty="0">
-                <a:solidFill>
-                  <a:srgbClr val="E5484D"/>
-                </a:solidFill>
-                <a:latin typeface="Calibri" pitchFamily="34" charset="0"/>
-                <a:ea typeface="Calibri" pitchFamily="34" charset="-122"/>
-                <a:cs typeface="Calibri" pitchFamily="34" charset="-120"/>
-              </a:rPr>
-              <a:t>✕</a:t>
-            </a:r>
-            <a:endParaRPr lang="en-US" sz="1300" dirty="0"/>
-          </a:p>
-        </p:txBody>
-      </p:sp>
-      <p:sp>
-        <p:nvSpPr>
-          <p:cNvPr id="15" name="Text 13"/>
-          <p:cNvSpPr/>
-          <p:nvPr/>
-        </p:nvSpPr>
-        <p:spPr>
-          <a:xfrm>
-            <a:off x="1243584" y="2185416"/>
+              <a:rPr lang="en-US" sz="900" b="1" dirty="0">
+                <a:solidFill>
+                  <a:srgbClr val="E0900C"/>
+                </a:solidFill>
+                <a:latin typeface="Calibri" pitchFamily="34" charset="0"/>
+                <a:ea typeface="Calibri" pitchFamily="34" charset="-122"/>
+                <a:cs typeface="Calibri" pitchFamily="34" charset="-120"/>
+              </a:rPr>
+              <a:t>●</a:t>
+            </a:r>
+            <a:endParaRPr lang="en-US" sz="900" dirty="0"/>
+          </a:p>
+        </p:txBody>
+      </p:sp>
+      <p:sp>
+        <p:nvSpPr>
+          <p:cNvPr id="16" name="Text 14"/>
+          <p:cNvSpPr/>
+          <p:nvPr/>
+        </p:nvSpPr>
+        <p:spPr>
+          <a:xfrm>
+            <a:off x="1243584" y="2624328"/>
             <a:ext cx="4434840" cy="292608"/>
           </a:xfrm>
           <a:prstGeom prst="rect">
@@ -34029,7 +34068,7 @@
                 <a:ea typeface="Calibri" pitchFamily="34" charset="-122"/>
                 <a:cs typeface="Calibri" pitchFamily="34" charset="-120"/>
               </a:rPr>
-              <a:t>Weeks to a number</a:t>
+              <a:t>Trusted &amp; thorough</a:t>
             </a:r>
             <a:endParaRPr lang="en-US" sz="1250" dirty="0"/>
           </a:p>
@@ -34037,13 +34076,13 @@
       </p:sp>
       <p:sp>
         <p:nvSpPr>
-          <p:cNvPr id="16" name="Text 14"/>
-          <p:cNvSpPr/>
-          <p:nvPr/>
-        </p:nvSpPr>
-        <p:spPr>
-          <a:xfrm>
-            <a:off x="1243584" y="2496312"/>
+          <p:cNvPr id="17" name="Text 15"/>
+          <p:cNvSpPr/>
+          <p:nvPr/>
+        </p:nvSpPr>
+        <p:spPr>
+          <a:xfrm>
+            <a:off x="1243584" y="2935224"/>
             <a:ext cx="4389120" cy="365760"/>
           </a:xfrm>
           <a:prstGeom prst="rect">
@@ -34068,7 +34107,7 @@
                 <a:ea typeface="Calibri" pitchFamily="34" charset="-122"/>
                 <a:cs typeface="Calibri" pitchFamily="34" charset="-120"/>
               </a:rPr>
-              <a:t>2–6 week RFQ cycles just to learn a price</a:t>
+              <a:t>a rigorous bottom-up method across every commodity</a:t>
             </a:r>
             <a:endParaRPr lang="en-US" sz="1000" dirty="0"/>
           </a:p>
@@ -34076,33 +34115,33 @@
       </p:sp>
       <p:sp>
         <p:nvSpPr>
-          <p:cNvPr id="17" name="Shape 15"/>
-          <p:cNvSpPr/>
-          <p:nvPr/>
-        </p:nvSpPr>
-        <p:spPr>
-          <a:xfrm>
-            <a:off x="804672" y="2971800"/>
+          <p:cNvPr id="18" name="Shape 16"/>
+          <p:cNvSpPr/>
+          <p:nvPr/>
+        </p:nvSpPr>
+        <p:spPr>
+          <a:xfrm>
+            <a:off x="804672" y="3337560"/>
             <a:ext cx="329184" cy="329184"/>
           </a:xfrm>
           <a:prstGeom prst="ellipse">
             <a:avLst/>
           </a:prstGeom>
           <a:solidFill>
-            <a:srgbClr val="FDECEC"/>
-          </a:solidFill>
-          <a:ln/>
-        </p:spPr>
-      </p:sp>
-      <p:sp>
-        <p:nvSpPr>
-          <p:cNvPr id="18" name="Text 16"/>
-          <p:cNvSpPr/>
-          <p:nvPr/>
-        </p:nvSpPr>
-        <p:spPr>
-          <a:xfrm>
-            <a:off x="804672" y="2962656"/>
+            <a:srgbClr val="FEF6E7"/>
+          </a:solidFill>
+          <a:ln/>
+        </p:spPr>
+      </p:sp>
+      <p:sp>
+        <p:nvSpPr>
+          <p:cNvPr id="19" name="Text 17"/>
+          <p:cNvSpPr/>
+          <p:nvPr/>
+        </p:nvSpPr>
+        <p:spPr>
+          <a:xfrm>
+            <a:off x="804672" y="3328416"/>
             <a:ext cx="329184" cy="329184"/>
           </a:xfrm>
           <a:prstGeom prst="rect">
@@ -34119,29 +34158,29 @@
               <a:buNone/>
             </a:pPr>
             <a:r>
-              <a:rPr lang="en-US" sz="1300" b="1" dirty="0">
-                <a:solidFill>
-                  <a:srgbClr val="E5484D"/>
-                </a:solidFill>
-                <a:latin typeface="Calibri" pitchFamily="34" charset="0"/>
-                <a:ea typeface="Calibri" pitchFamily="34" charset="-122"/>
-                <a:cs typeface="Calibri" pitchFamily="34" charset="-120"/>
-              </a:rPr>
-              <a:t>✕</a:t>
-            </a:r>
-            <a:endParaRPr lang="en-US" sz="1300" dirty="0"/>
-          </a:p>
-        </p:txBody>
-      </p:sp>
-      <p:sp>
-        <p:nvSpPr>
-          <p:cNvPr id="19" name="Text 17"/>
-          <p:cNvSpPr/>
-          <p:nvPr/>
-        </p:nvSpPr>
-        <p:spPr>
-          <a:xfrm>
-            <a:off x="1243584" y="2916936"/>
+              <a:rPr lang="en-US" sz="900" b="1" dirty="0">
+                <a:solidFill>
+                  <a:srgbClr val="E0900C"/>
+                </a:solidFill>
+                <a:latin typeface="Calibri" pitchFamily="34" charset="0"/>
+                <a:ea typeface="Calibri" pitchFamily="34" charset="-122"/>
+                <a:cs typeface="Calibri" pitchFamily="34" charset="-120"/>
+              </a:rPr>
+              <a:t>●</a:t>
+            </a:r>
+            <a:endParaRPr lang="en-US" sz="900" dirty="0"/>
+          </a:p>
+        </p:txBody>
+      </p:sp>
+      <p:sp>
+        <p:nvSpPr>
+          <p:cNvPr id="20" name="Text 18"/>
+          <p:cNvSpPr/>
+          <p:nvPr/>
+        </p:nvSpPr>
+        <p:spPr>
+          <a:xfrm>
+            <a:off x="1243584" y="3282696"/>
             <a:ext cx="4434840" cy="292608"/>
           </a:xfrm>
           <a:prstGeom prst="rect">
@@ -34166,7 +34205,7 @@
                 <a:ea typeface="Calibri" pitchFamily="34" charset="-122"/>
                 <a:cs typeface="Calibri" pitchFamily="34" charset="-120"/>
               </a:rPr>
-              <a:t>A price, no breakdown</a:t>
+              <a:t>Hands-on setup</a:t>
             </a:r>
             <a:endParaRPr lang="en-US" sz="1250" dirty="0"/>
           </a:p>
@@ -34174,13 +34213,13 @@
       </p:sp>
       <p:sp>
         <p:nvSpPr>
-          <p:cNvPr id="20" name="Text 18"/>
-          <p:cNvSpPr/>
-          <p:nvPr/>
-        </p:nvSpPr>
-        <p:spPr>
-          <a:xfrm>
-            <a:off x="1243584" y="3227832"/>
+          <p:cNvPr id="21" name="Text 19"/>
+          <p:cNvSpPr/>
+          <p:nvPr/>
+        </p:nvSpPr>
+        <p:spPr>
+          <a:xfrm>
+            <a:off x="1243584" y="3593592"/>
             <a:ext cx="4389120" cy="365760"/>
           </a:xfrm>
           <a:prstGeom prst="rect">
@@ -34205,7 +34244,7 @@
                 <a:ea typeface="Calibri" pitchFamily="34" charset="-122"/>
                 <a:cs typeface="Calibri" pitchFamily="34" charset="-120"/>
               </a:rPr>
-              <a:t>no line-of-sight into material vs process vs margin</a:t>
+              <a:t>material, process &amp; machine selected manually, part by part</a:t>
             </a:r>
             <a:endParaRPr lang="en-US" sz="1000" dirty="0"/>
           </a:p>
@@ -34213,33 +34252,33 @@
       </p:sp>
       <p:sp>
         <p:nvSpPr>
-          <p:cNvPr id="21" name="Shape 19"/>
-          <p:cNvSpPr/>
-          <p:nvPr/>
-        </p:nvSpPr>
-        <p:spPr>
-          <a:xfrm>
-            <a:off x="804672" y="3703320"/>
+          <p:cNvPr id="22" name="Shape 20"/>
+          <p:cNvSpPr/>
+          <p:nvPr/>
+        </p:nvSpPr>
+        <p:spPr>
+          <a:xfrm>
+            <a:off x="804672" y="3995928"/>
             <a:ext cx="329184" cy="329184"/>
           </a:xfrm>
           <a:prstGeom prst="ellipse">
             <a:avLst/>
           </a:prstGeom>
           <a:solidFill>
-            <a:srgbClr val="FDECEC"/>
-          </a:solidFill>
-          <a:ln/>
-        </p:spPr>
-      </p:sp>
-      <p:sp>
-        <p:nvSpPr>
-          <p:cNvPr id="22" name="Text 20"/>
-          <p:cNvSpPr/>
-          <p:nvPr/>
-        </p:nvSpPr>
-        <p:spPr>
-          <a:xfrm>
-            <a:off x="804672" y="3694176"/>
+            <a:srgbClr val="FEF6E7"/>
+          </a:solidFill>
+          <a:ln/>
+        </p:spPr>
+      </p:sp>
+      <p:sp>
+        <p:nvSpPr>
+          <p:cNvPr id="23" name="Text 21"/>
+          <p:cNvSpPr/>
+          <p:nvPr/>
+        </p:nvSpPr>
+        <p:spPr>
+          <a:xfrm>
+            <a:off x="804672" y="3986784"/>
             <a:ext cx="329184" cy="329184"/>
           </a:xfrm>
           <a:prstGeom prst="rect">
@@ -34256,29 +34295,29 @@
               <a:buNone/>
             </a:pPr>
             <a:r>
-              <a:rPr lang="en-US" sz="1300" b="1" dirty="0">
-                <a:solidFill>
-                  <a:srgbClr val="E5484D"/>
-                </a:solidFill>
-                <a:latin typeface="Calibri" pitchFamily="34" charset="0"/>
-                <a:ea typeface="Calibri" pitchFamily="34" charset="-122"/>
-                <a:cs typeface="Calibri" pitchFamily="34" charset="-120"/>
-              </a:rPr>
-              <a:t>✕</a:t>
-            </a:r>
-            <a:endParaRPr lang="en-US" sz="1300" dirty="0"/>
-          </a:p>
-        </p:txBody>
-      </p:sp>
-      <p:sp>
-        <p:nvSpPr>
-          <p:cNvPr id="23" name="Text 21"/>
-          <p:cNvSpPr/>
-          <p:nvPr/>
-        </p:nvSpPr>
-        <p:spPr>
-          <a:xfrm>
-            <a:off x="1243584" y="3648456"/>
+              <a:rPr lang="en-US" sz="900" b="1" dirty="0">
+                <a:solidFill>
+                  <a:srgbClr val="E0900C"/>
+                </a:solidFill>
+                <a:latin typeface="Calibri" pitchFamily="34" charset="0"/>
+                <a:ea typeface="Calibri" pitchFamily="34" charset="-122"/>
+                <a:cs typeface="Calibri" pitchFamily="34" charset="-120"/>
+              </a:rPr>
+              <a:t>●</a:t>
+            </a:r>
+            <a:endParaRPr lang="en-US" sz="900" dirty="0"/>
+          </a:p>
+        </p:txBody>
+      </p:sp>
+      <p:sp>
+        <p:nvSpPr>
+          <p:cNvPr id="24" name="Text 22"/>
+          <p:cNvSpPr/>
+          <p:nvPr/>
+        </p:nvSpPr>
+        <p:spPr>
+          <a:xfrm>
+            <a:off x="1243584" y="3941064"/>
             <a:ext cx="4434840" cy="292608"/>
           </a:xfrm>
           <a:prstGeom prst="rect">
@@ -34303,7 +34342,7 @@
                 <a:ea typeface="Calibri" pitchFamily="34" charset="-122"/>
                 <a:cs typeface="Calibri" pitchFamily="34" charset="-120"/>
               </a:rPr>
-              <a:t>Depends on who did it</a:t>
+              <a:t>Manual data entry</a:t>
             </a:r>
             <a:endParaRPr lang="en-US" sz="1250" dirty="0"/>
           </a:p>
@@ -34311,13 +34350,13 @@
       </p:sp>
       <p:sp>
         <p:nvSpPr>
-          <p:cNvPr id="24" name="Text 22"/>
-          <p:cNvSpPr/>
-          <p:nvPr/>
-        </p:nvSpPr>
-        <p:spPr>
-          <a:xfrm>
-            <a:off x="1243584" y="3959352"/>
+          <p:cNvPr id="25" name="Text 23"/>
+          <p:cNvSpPr/>
+          <p:nvPr/>
+        </p:nvSpPr>
+        <p:spPr>
+          <a:xfrm>
+            <a:off x="1243584" y="4251960"/>
             <a:ext cx="4389120" cy="365760"/>
           </a:xfrm>
           <a:prstGeom prst="rect">
@@ -34342,7 +34381,7 @@
                 <a:ea typeface="Calibri" pitchFamily="34" charset="-122"/>
                 <a:cs typeface="Calibri" pitchFamily="34" charset="-120"/>
               </a:rPr>
-              <a:t>two estimators, two answers — no single source of truth</a:t>
+              <a:t>geometry &amp; tolerances read off 3D CAD and drawings by hand</a:t>
             </a:r>
             <a:endParaRPr lang="en-US" sz="1000" dirty="0"/>
           </a:p>
@@ -34350,33 +34389,33 @@
       </p:sp>
       <p:sp>
         <p:nvSpPr>
-          <p:cNvPr id="25" name="Shape 23"/>
-          <p:cNvSpPr/>
-          <p:nvPr/>
-        </p:nvSpPr>
-        <p:spPr>
-          <a:xfrm>
-            <a:off x="804672" y="4434840"/>
+          <p:cNvPr id="26" name="Shape 24"/>
+          <p:cNvSpPr/>
+          <p:nvPr/>
+        </p:nvSpPr>
+        <p:spPr>
+          <a:xfrm>
+            <a:off x="804672" y="4654296"/>
             <a:ext cx="329184" cy="329184"/>
           </a:xfrm>
           <a:prstGeom prst="ellipse">
             <a:avLst/>
           </a:prstGeom>
           <a:solidFill>
-            <a:srgbClr val="FDECEC"/>
-          </a:solidFill>
-          <a:ln/>
-        </p:spPr>
-      </p:sp>
-      <p:sp>
-        <p:nvSpPr>
-          <p:cNvPr id="26" name="Text 24"/>
-          <p:cNvSpPr/>
-          <p:nvPr/>
-        </p:nvSpPr>
-        <p:spPr>
-          <a:xfrm>
-            <a:off x="804672" y="4425696"/>
+            <a:srgbClr val="FEF6E7"/>
+          </a:solidFill>
+          <a:ln/>
+        </p:spPr>
+      </p:sp>
+      <p:sp>
+        <p:nvSpPr>
+          <p:cNvPr id="27" name="Text 25"/>
+          <p:cNvSpPr/>
+          <p:nvPr/>
+        </p:nvSpPr>
+        <p:spPr>
+          <a:xfrm>
+            <a:off x="804672" y="4645152"/>
             <a:ext cx="329184" cy="329184"/>
           </a:xfrm>
           <a:prstGeom prst="rect">
@@ -34393,29 +34432,29 @@
               <a:buNone/>
             </a:pPr>
             <a:r>
-              <a:rPr lang="en-US" sz="1300" b="1" dirty="0">
-                <a:solidFill>
-                  <a:srgbClr val="E5484D"/>
-                </a:solidFill>
-                <a:latin typeface="Calibri" pitchFamily="34" charset="0"/>
-                <a:ea typeface="Calibri" pitchFamily="34" charset="-122"/>
-                <a:cs typeface="Calibri" pitchFamily="34" charset="-120"/>
-              </a:rPr>
-              <a:t>✕</a:t>
-            </a:r>
-            <a:endParaRPr lang="en-US" sz="1300" dirty="0"/>
-          </a:p>
-        </p:txBody>
-      </p:sp>
-      <p:sp>
-        <p:nvSpPr>
-          <p:cNvPr id="27" name="Text 25"/>
-          <p:cNvSpPr/>
-          <p:nvPr/>
-        </p:nvSpPr>
-        <p:spPr>
-          <a:xfrm>
-            <a:off x="1243584" y="4379976"/>
+              <a:rPr lang="en-US" sz="900" b="1" dirty="0">
+                <a:solidFill>
+                  <a:srgbClr val="E0900C"/>
+                </a:solidFill>
+                <a:latin typeface="Calibri" pitchFamily="34" charset="0"/>
+                <a:ea typeface="Calibri" pitchFamily="34" charset="-122"/>
+                <a:cs typeface="Calibri" pitchFamily="34" charset="-120"/>
+              </a:rPr>
+              <a:t>●</a:t>
+            </a:r>
+            <a:endParaRPr lang="en-US" sz="900" dirty="0"/>
+          </a:p>
+        </p:txBody>
+      </p:sp>
+      <p:sp>
+        <p:nvSpPr>
+          <p:cNvPr id="28" name="Text 26"/>
+          <p:cNvSpPr/>
+          <p:nvPr/>
+        </p:nvSpPr>
+        <p:spPr>
+          <a:xfrm>
+            <a:off x="1243584" y="4599432"/>
             <a:ext cx="4434840" cy="292608"/>
           </a:xfrm>
           <a:prstGeom prst="rect">
@@ -34440,7 +34479,7 @@
                 <a:ea typeface="Calibri" pitchFamily="34" charset="-122"/>
                 <a:cs typeface="Calibri" pitchFamily="34" charset="-120"/>
               </a:rPr>
-              <a:t>Knowledge walks out</a:t>
+              <a:t>Updated by hand</a:t>
             </a:r>
             <a:endParaRPr lang="en-US" sz="1250" dirty="0"/>
           </a:p>
@@ -34448,13 +34487,13 @@
       </p:sp>
       <p:sp>
         <p:nvSpPr>
-          <p:cNvPr id="28" name="Text 26"/>
-          <p:cNvSpPr/>
-          <p:nvPr/>
-        </p:nvSpPr>
-        <p:spPr>
-          <a:xfrm>
-            <a:off x="1243584" y="4690872"/>
+          <p:cNvPr id="29" name="Text 27"/>
+          <p:cNvSpPr/>
+          <p:nvPr/>
+        </p:nvSpPr>
+        <p:spPr>
+          <a:xfrm>
+            <a:off x="1243584" y="4910328"/>
             <a:ext cx="4389120" cy="365760"/>
           </a:xfrm>
           <a:prstGeom prst="rect">
@@ -34479,7 +34518,7 @@
                 <a:ea typeface="Calibri" pitchFamily="34" charset="-122"/>
                 <a:cs typeface="Calibri" pitchFamily="34" charset="-120"/>
               </a:rPr>
-              <a:t>senior judgement leaves when people do</a:t>
+              <a:t>rates &amp; inputs refreshed manually as economics change</a:t>
             </a:r>
             <a:endParaRPr lang="en-US" sz="1000" dirty="0"/>
           </a:p>
@@ -34487,18 +34526,18 @@
       </p:sp>
       <p:sp>
         <p:nvSpPr>
-          <p:cNvPr id="29" name="Shape 27"/>
-          <p:cNvSpPr/>
-          <p:nvPr/>
-        </p:nvSpPr>
-        <p:spPr>
-          <a:xfrm>
-            <a:off x="6291072" y="1600200"/>
-            <a:ext cx="5349240" cy="3657600"/>
+          <p:cNvPr id="30" name="Shape 28"/>
+          <p:cNvSpPr/>
+          <p:nvPr/>
+        </p:nvSpPr>
+        <p:spPr>
+          <a:xfrm>
+            <a:off x="6291072" y="2057400"/>
+            <a:ext cx="5349240" cy="3246120"/>
           </a:xfrm>
           <a:prstGeom prst="roundRect">
             <a:avLst>
-              <a:gd name="adj" fmla="val 1750"/>
+              <a:gd name="adj" fmla="val 1972"/>
             </a:avLst>
           </a:prstGeom>
           <a:solidFill>
@@ -34514,13 +34553,13 @@
       </p:sp>
       <p:sp>
         <p:nvSpPr>
-          <p:cNvPr id="30" name="Shape 28"/>
-          <p:cNvSpPr/>
-          <p:nvPr/>
-        </p:nvSpPr>
-        <p:spPr>
-          <a:xfrm>
-            <a:off x="6291072" y="1600200"/>
+          <p:cNvPr id="31" name="Shape 29"/>
+          <p:cNvSpPr/>
+          <p:nvPr/>
+        </p:nvSpPr>
+        <p:spPr>
+          <a:xfrm>
+            <a:off x="6291072" y="2057400"/>
             <a:ext cx="5349240" cy="457200"/>
           </a:xfrm>
           <a:prstGeom prst="rect">
@@ -34534,13 +34573,13 @@
       </p:sp>
       <p:sp>
         <p:nvSpPr>
-          <p:cNvPr id="31" name="Text 29"/>
-          <p:cNvSpPr/>
-          <p:nvPr/>
-        </p:nvSpPr>
-        <p:spPr>
-          <a:xfrm>
-            <a:off x="6565392" y="1600200"/>
+          <p:cNvPr id="32" name="Text 30"/>
+          <p:cNvSpPr/>
+          <p:nvPr/>
+        </p:nvSpPr>
+        <p:spPr>
+          <a:xfrm>
+            <a:off x="6565392" y="2057400"/>
             <a:ext cx="4892040" cy="457200"/>
           </a:xfrm>
           <a:prstGeom prst="rect">
@@ -34565,7 +34604,7 @@
                 <a:ea typeface="Calibri" pitchFamily="34" charset="-122"/>
                 <a:cs typeface="Calibri" pitchFamily="34" charset="-120"/>
               </a:rPr>
-              <a:t>WITH COSTVISION</a:t>
+              <a:t>WITH COSTVISION  ·  automated &amp; AI-assisted</a:t>
             </a:r>
             <a:endParaRPr lang="en-US" sz="1300" dirty="0"/>
           </a:p>
@@ -34573,13 +34612,13 @@
       </p:sp>
       <p:sp>
         <p:nvSpPr>
-          <p:cNvPr id="32" name="Shape 30"/>
-          <p:cNvSpPr/>
-          <p:nvPr/>
-        </p:nvSpPr>
-        <p:spPr>
-          <a:xfrm>
-            <a:off x="6547104" y="2240280"/>
+          <p:cNvPr id="33" name="Shape 31"/>
+          <p:cNvSpPr/>
+          <p:nvPr/>
+        </p:nvSpPr>
+        <p:spPr>
+          <a:xfrm>
+            <a:off x="6547104" y="2679192"/>
             <a:ext cx="329184" cy="329184"/>
           </a:xfrm>
           <a:prstGeom prst="ellipse">
@@ -34593,13 +34632,13 @@
       </p:sp>
       <p:sp>
         <p:nvSpPr>
-          <p:cNvPr id="33" name="Text 31"/>
-          <p:cNvSpPr/>
-          <p:nvPr/>
-        </p:nvSpPr>
-        <p:spPr>
-          <a:xfrm>
-            <a:off x="6547104" y="2231136"/>
+          <p:cNvPr id="34" name="Text 32"/>
+          <p:cNvSpPr/>
+          <p:nvPr/>
+        </p:nvSpPr>
+        <p:spPr>
+          <a:xfrm>
+            <a:off x="6547104" y="2670048"/>
             <a:ext cx="329184" cy="329184"/>
           </a:xfrm>
           <a:prstGeom prst="rect">
@@ -34632,13 +34671,13 @@
       </p:sp>
       <p:sp>
         <p:nvSpPr>
-          <p:cNvPr id="34" name="Text 32"/>
-          <p:cNvSpPr/>
-          <p:nvPr/>
-        </p:nvSpPr>
-        <p:spPr>
-          <a:xfrm>
-            <a:off x="6986016" y="2185416"/>
+          <p:cNvPr id="35" name="Text 33"/>
+          <p:cNvSpPr/>
+          <p:nvPr/>
+        </p:nvSpPr>
+        <p:spPr>
+          <a:xfrm>
+            <a:off x="6986016" y="2624328"/>
             <a:ext cx="4434840" cy="292608"/>
           </a:xfrm>
           <a:prstGeom prst="rect">
@@ -34663,7 +34702,7 @@
                 <a:ea typeface="Calibri" pitchFamily="34" charset="-122"/>
                 <a:cs typeface="Calibri" pitchFamily="34" charset="-120"/>
               </a:rPr>
-              <a:t>Minutes to a number</a:t>
+              <a:t>Same rigour, automated</a:t>
             </a:r>
             <a:endParaRPr lang="en-US" sz="1250" dirty="0"/>
           </a:p>
@@ -34671,13 +34710,13 @@
       </p:sp>
       <p:sp>
         <p:nvSpPr>
-          <p:cNvPr id="35" name="Text 33"/>
-          <p:cNvSpPr/>
-          <p:nvPr/>
-        </p:nvSpPr>
-        <p:spPr>
-          <a:xfrm>
-            <a:off x="6986016" y="2496312"/>
+          <p:cNvPr id="36" name="Text 34"/>
+          <p:cNvSpPr/>
+          <p:nvPr/>
+        </p:nvSpPr>
+        <p:spPr>
+          <a:xfrm>
+            <a:off x="6986016" y="2935224"/>
             <a:ext cx="4389120" cy="365760"/>
           </a:xfrm>
           <a:prstGeom prst="rect">
@@ -34702,7 +34741,7 @@
                 <a:ea typeface="Calibri" pitchFamily="34" charset="-122"/>
                 <a:cs typeface="Calibri" pitchFamily="34" charset="-120"/>
               </a:rPr>
-              <a:t>CAD, photo or description → costed in minutes</a:t>
+              <a:t>the deterministic method you trust — the manual steps removed</a:t>
             </a:r>
             <a:endParaRPr lang="en-US" sz="1000" dirty="0"/>
           </a:p>
@@ -34710,13 +34749,13 @@
       </p:sp>
       <p:sp>
         <p:nvSpPr>
-          <p:cNvPr id="36" name="Shape 34"/>
-          <p:cNvSpPr/>
-          <p:nvPr/>
-        </p:nvSpPr>
-        <p:spPr>
-          <a:xfrm>
-            <a:off x="6547104" y="2971800"/>
+          <p:cNvPr id="37" name="Shape 35"/>
+          <p:cNvSpPr/>
+          <p:nvPr/>
+        </p:nvSpPr>
+        <p:spPr>
+          <a:xfrm>
+            <a:off x="6547104" y="3337560"/>
             <a:ext cx="329184" cy="329184"/>
           </a:xfrm>
           <a:prstGeom prst="ellipse">
@@ -34730,13 +34769,13 @@
       </p:sp>
       <p:sp>
         <p:nvSpPr>
-          <p:cNvPr id="37" name="Text 35"/>
-          <p:cNvSpPr/>
-          <p:nvPr/>
-        </p:nvSpPr>
-        <p:spPr>
-          <a:xfrm>
-            <a:off x="6547104" y="2962656"/>
+          <p:cNvPr id="38" name="Text 36"/>
+          <p:cNvSpPr/>
+          <p:nvPr/>
+        </p:nvSpPr>
+        <p:spPr>
+          <a:xfrm>
+            <a:off x="6547104" y="3328416"/>
             <a:ext cx="329184" cy="329184"/>
           </a:xfrm>
           <a:prstGeom prst="rect">
@@ -34769,13 +34808,13 @@
       </p:sp>
       <p:sp>
         <p:nvSpPr>
-          <p:cNvPr id="38" name="Text 36"/>
-          <p:cNvSpPr/>
-          <p:nvPr/>
-        </p:nvSpPr>
-        <p:spPr>
-          <a:xfrm>
-            <a:off x="6986016" y="2916936"/>
+          <p:cNvPr id="39" name="Text 37"/>
+          <p:cNvSpPr/>
+          <p:nvPr/>
+        </p:nvSpPr>
+        <p:spPr>
+          <a:xfrm>
+            <a:off x="6986016" y="3282696"/>
             <a:ext cx="4434840" cy="292608"/>
           </a:xfrm>
           <a:prstGeom prst="rect">
@@ -34800,7 +34839,7 @@
                 <a:ea typeface="Calibri" pitchFamily="34" charset="-122"/>
                 <a:cs typeface="Calibri" pitchFamily="34" charset="-120"/>
               </a:rPr>
-              <a:t>Full breakdown</a:t>
+              <a:t>Reads CAD &amp; drawings</a:t>
             </a:r>
             <a:endParaRPr lang="en-US" sz="1250" dirty="0"/>
           </a:p>
@@ -34808,13 +34847,13 @@
       </p:sp>
       <p:sp>
         <p:nvSpPr>
-          <p:cNvPr id="39" name="Text 37"/>
-          <p:cNvSpPr/>
-          <p:nvPr/>
-        </p:nvSpPr>
-        <p:spPr>
-          <a:xfrm>
-            <a:off x="6986016" y="3227832"/>
+          <p:cNvPr id="40" name="Text 38"/>
+          <p:cNvSpPr/>
+          <p:nvPr/>
+        </p:nvSpPr>
+        <p:spPr>
+          <a:xfrm>
+            <a:off x="6986016" y="3593592"/>
             <a:ext cx="4389120" cy="365760"/>
           </a:xfrm>
           <a:prstGeom prst="rect">
@@ -34839,7 +34878,7 @@
                 <a:ea typeface="Calibri" pitchFamily="34" charset="-122"/>
                 <a:cs typeface="Calibri" pitchFamily="34" charset="-120"/>
               </a:rPr>
-              <a:t>every £ traced to material, process, region, margin</a:t>
+              <a:t>geometry, features &amp; tolerances extracted automatically</a:t>
             </a:r>
             <a:endParaRPr lang="en-US" sz="1000" dirty="0"/>
           </a:p>
@@ -34847,13 +34886,13 @@
       </p:sp>
       <p:sp>
         <p:nvSpPr>
-          <p:cNvPr id="40" name="Shape 38"/>
-          <p:cNvSpPr/>
-          <p:nvPr/>
-        </p:nvSpPr>
-        <p:spPr>
-          <a:xfrm>
-            <a:off x="6547104" y="3703320"/>
+          <p:cNvPr id="41" name="Shape 39"/>
+          <p:cNvSpPr/>
+          <p:nvPr/>
+        </p:nvSpPr>
+        <p:spPr>
+          <a:xfrm>
+            <a:off x="6547104" y="3995928"/>
             <a:ext cx="329184" cy="329184"/>
           </a:xfrm>
           <a:prstGeom prst="ellipse">
@@ -34867,13 +34906,13 @@
       </p:sp>
       <p:sp>
         <p:nvSpPr>
-          <p:cNvPr id="41" name="Text 39"/>
-          <p:cNvSpPr/>
-          <p:nvPr/>
-        </p:nvSpPr>
-        <p:spPr>
-          <a:xfrm>
-            <a:off x="6547104" y="3694176"/>
+          <p:cNvPr id="42" name="Text 40"/>
+          <p:cNvSpPr/>
+          <p:nvPr/>
+        </p:nvSpPr>
+        <p:spPr>
+          <a:xfrm>
+            <a:off x="6547104" y="3986784"/>
             <a:ext cx="329184" cy="329184"/>
           </a:xfrm>
           <a:prstGeom prst="rect">
@@ -34906,13 +34945,13 @@
       </p:sp>
       <p:sp>
         <p:nvSpPr>
-          <p:cNvPr id="42" name="Text 40"/>
-          <p:cNvSpPr/>
-          <p:nvPr/>
-        </p:nvSpPr>
-        <p:spPr>
-          <a:xfrm>
-            <a:off x="6986016" y="3648456"/>
+          <p:cNvPr id="43" name="Text 41"/>
+          <p:cNvSpPr/>
+          <p:nvPr/>
+        </p:nvSpPr>
+        <p:spPr>
+          <a:xfrm>
+            <a:off x="6986016" y="3941064"/>
             <a:ext cx="4434840" cy="292608"/>
           </a:xfrm>
           <a:prstGeom prst="rect">
@@ -34937,7 +34976,7 @@
                 <a:ea typeface="Calibri" pitchFamily="34" charset="-122"/>
                 <a:cs typeface="Calibri" pitchFamily="34" charset="-120"/>
               </a:rPr>
-              <a:t>One consistent answer</a:t>
+              <a:t>AI suggests, you decide</a:t>
             </a:r>
             <a:endParaRPr lang="en-US" sz="1250" dirty="0"/>
           </a:p>
@@ -34945,13 +34984,13 @@
       </p:sp>
       <p:sp>
         <p:nvSpPr>
-          <p:cNvPr id="43" name="Text 41"/>
-          <p:cNvSpPr/>
-          <p:nvPr/>
-        </p:nvSpPr>
-        <p:spPr>
-          <a:xfrm>
-            <a:off x="6986016" y="3959352"/>
+          <p:cNvPr id="44" name="Text 42"/>
+          <p:cNvSpPr/>
+          <p:nvPr/>
+        </p:nvSpPr>
+        <p:spPr>
+          <a:xfrm>
+            <a:off x="6986016" y="4251960"/>
             <a:ext cx="4389120" cy="365760"/>
           </a:xfrm>
           <a:prstGeom prst="rect">
@@ -34976,7 +35015,7 @@
                 <a:ea typeface="Calibri" pitchFamily="34" charset="-122"/>
                 <a:cs typeface="Calibri" pitchFamily="34" charset="-120"/>
               </a:rPr>
-              <a:t>deterministic engine — same part, same cost, every time</a:t>
+              <a:t>material &amp; process proposed with a confidence score to confirm</a:t>
             </a:r>
             <a:endParaRPr lang="en-US" sz="1000" dirty="0"/>
           </a:p>
@@ -34984,13 +35023,13 @@
       </p:sp>
       <p:sp>
         <p:nvSpPr>
-          <p:cNvPr id="44" name="Shape 42"/>
-          <p:cNvSpPr/>
-          <p:nvPr/>
-        </p:nvSpPr>
-        <p:spPr>
-          <a:xfrm>
-            <a:off x="6547104" y="4434840"/>
+          <p:cNvPr id="45" name="Shape 43"/>
+          <p:cNvSpPr/>
+          <p:nvPr/>
+        </p:nvSpPr>
+        <p:spPr>
+          <a:xfrm>
+            <a:off x="6547104" y="4654296"/>
             <a:ext cx="329184" cy="329184"/>
           </a:xfrm>
           <a:prstGeom prst="ellipse">
@@ -35004,13 +35043,13 @@
       </p:sp>
       <p:sp>
         <p:nvSpPr>
-          <p:cNvPr id="45" name="Text 43"/>
-          <p:cNvSpPr/>
-          <p:nvPr/>
-        </p:nvSpPr>
-        <p:spPr>
-          <a:xfrm>
-            <a:off x="6547104" y="4425696"/>
+          <p:cNvPr id="46" name="Text 44"/>
+          <p:cNvSpPr/>
+          <p:nvPr/>
+        </p:nvSpPr>
+        <p:spPr>
+          <a:xfrm>
+            <a:off x="6547104" y="4645152"/>
             <a:ext cx="329184" cy="329184"/>
           </a:xfrm>
           <a:prstGeom prst="rect">
@@ -35043,13 +35082,13 @@
       </p:sp>
       <p:sp>
         <p:nvSpPr>
-          <p:cNvPr id="46" name="Text 44"/>
-          <p:cNvSpPr/>
-          <p:nvPr/>
-        </p:nvSpPr>
-        <p:spPr>
-          <a:xfrm>
-            <a:off x="6986016" y="4379976"/>
+          <p:cNvPr id="47" name="Text 45"/>
+          <p:cNvSpPr/>
+          <p:nvPr/>
+        </p:nvSpPr>
+        <p:spPr>
+          <a:xfrm>
+            <a:off x="6986016" y="4599432"/>
             <a:ext cx="4434840" cy="292608"/>
           </a:xfrm>
           <a:prstGeom prst="rect">
@@ -35074,7 +35113,7 @@
                 <a:ea typeface="Calibri" pitchFamily="34" charset="-122"/>
                 <a:cs typeface="Calibri" pitchFamily="34" charset="-120"/>
               </a:rPr>
-              <a:t>Knowledge compounds</a:t>
+              <a:t>Always current</a:t>
             </a:r>
             <a:endParaRPr lang="en-US" sz="1250" dirty="0"/>
           </a:p>
@@ -35082,13 +35121,13 @@
       </p:sp>
       <p:sp>
         <p:nvSpPr>
-          <p:cNvPr id="47" name="Text 45"/>
-          <p:cNvSpPr/>
-          <p:nvPr/>
-        </p:nvSpPr>
-        <p:spPr>
-          <a:xfrm>
-            <a:off x="6986016" y="4690872"/>
+          <p:cNvPr id="48" name="Text 46"/>
+          <p:cNvSpPr/>
+          <p:nvPr/>
+        </p:nvSpPr>
+        <p:spPr>
+          <a:xfrm>
+            <a:off x="6986016" y="4910328"/>
             <a:ext cx="4389120" cy="365760"/>
           </a:xfrm>
           <a:prstGeom prst="rect">
@@ -35113,7 +35152,7 @@
                 <a:ea typeface="Calibri" pitchFamily="34" charset="-122"/>
                 <a:cs typeface="Calibri" pitchFamily="34" charset="-120"/>
               </a:rPr>
-              <a:t>every analysis &amp; quote becomes a company asset</a:t>
+              <a:t>rates auto-refresh — update once, every part re-prices</a:t>
             </a:r>
             <a:endParaRPr lang="en-US" sz="1000" dirty="0"/>
           </a:p>
@@ -35121,13 +35160,13 @@
       </p:sp>
       <p:sp>
         <p:nvSpPr>
-          <p:cNvPr id="48" name="Text 46"/>
-          <p:cNvSpPr/>
-          <p:nvPr/>
-        </p:nvSpPr>
-        <p:spPr>
-          <a:xfrm>
-            <a:off x="5952744" y="3154680"/>
+          <p:cNvPr id="49" name="Text 47"/>
+          <p:cNvSpPr/>
+          <p:nvPr/>
+        </p:nvSpPr>
+        <p:spPr>
+          <a:xfrm>
+            <a:off x="5952744" y="3429000"/>
             <a:ext cx="283464" cy="548640"/>
           </a:xfrm>
           <a:prstGeom prst="rect">
@@ -35146,7 +35185,7 @@
             <a:r>
               <a:rPr lang="en-US" sz="2600" b="1" dirty="0">
                 <a:solidFill>
-                  <a:srgbClr val="0EA472"/>
+                  <a:srgbClr val="2563EB"/>
                 </a:solidFill>
                 <a:latin typeface="Calibri" pitchFamily="34" charset="0"/>
                 <a:ea typeface="Calibri" pitchFamily="34" charset="-122"/>
@@ -35160,13 +35199,13 @@
       </p:sp>
       <p:sp>
         <p:nvSpPr>
-          <p:cNvPr id="49" name="Shape 47"/>
-          <p:cNvSpPr/>
-          <p:nvPr/>
-        </p:nvSpPr>
-        <p:spPr>
-          <a:xfrm>
-            <a:off x="548640" y="5486400"/>
+          <p:cNvPr id="50" name="Shape 48"/>
+          <p:cNvSpPr/>
+          <p:nvPr/>
+        </p:nvSpPr>
+        <p:spPr>
+          <a:xfrm>
+            <a:off x="548640" y="5504688"/>
             <a:ext cx="11091672" cy="566928"/>
           </a:xfrm>
           <a:prstGeom prst="roundRect">
@@ -35187,13 +35226,13 @@
       </p:sp>
       <p:sp>
         <p:nvSpPr>
-          <p:cNvPr id="50" name="Text 48"/>
-          <p:cNvSpPr/>
-          <p:nvPr/>
-        </p:nvSpPr>
-        <p:spPr>
-          <a:xfrm>
-            <a:off x="914400" y="5486400"/>
+          <p:cNvPr id="51" name="Text 49"/>
+          <p:cNvSpPr/>
+          <p:nvPr/>
+        </p:nvSpPr>
+        <p:spPr>
+          <a:xfrm>
+            <a:off x="914400" y="5504688"/>
             <a:ext cx="10332720" cy="566928"/>
           </a:xfrm>
           <a:prstGeom prst="rect">
@@ -35218,7 +35257,7 @@
                 <a:ea typeface="Calibri" pitchFamily="34" charset="-122"/>
                 <a:cs typeface="Calibri" pitchFamily="34" charset="-120"/>
               </a:rPr>
-              <a:t>The shift:  </a:t>
+              <a:t>The step forward:  </a:t>
             </a:r>
             <a:pPr indent="0" marL="0">
               <a:buNone/>
@@ -35232,7 +35271,7 @@
                 <a:ea typeface="Calibri" pitchFamily="34" charset="-122"/>
                 <a:cs typeface="Calibri" pitchFamily="34" charset="-120"/>
               </a:rPr>
-              <a:t>from a slow, opaque, person-dependent process to a fast, transparent, self-improving one — the same board or part, costed the same way, every time, by anyone on the team.</a:t>
+              <a:t>the same defensible should-cost, with the manual work automated and AI-assisted — so your experts spend their time on decisions, not data entry.</a:t>
             </a:r>
             <a:endParaRPr lang="en-US" sz="1200" dirty="0"/>
           </a:p>
@@ -35240,7 +35279,7 @@
       </p:sp>
       <p:sp>
         <p:nvSpPr>
-          <p:cNvPr id="51" name="Shape 49"/>
+          <p:cNvPr id="52" name="Shape 50"/>
           <p:cNvSpPr/>
           <p:nvPr/>
         </p:nvSpPr>
@@ -35260,7 +35299,7 @@
       </p:sp>
       <p:sp>
         <p:nvSpPr>
-          <p:cNvPr id="52" name="Text 50"/>
+          <p:cNvPr id="53" name="Text 51"/>
           <p:cNvSpPr/>
           <p:nvPr/>
         </p:nvSpPr>
@@ -35299,7 +35338,7 @@
       </p:sp>
       <p:sp>
         <p:nvSpPr>
-          <p:cNvPr id="53" name="Text 51"/>
+          <p:cNvPr id="54" name="Text 52"/>
           <p:cNvSpPr/>
           <p:nvPr/>
         </p:nvSpPr>

</xml_diff>

<commit_message>
Reword effort slide: 'custom code, built in-house (AI-accelerated)'
Replaces 'hand-written' framing to avoid implying sole personal authorship.
Credits the design, cost models and validation as in-house IP while being
transparent that development was AI-accelerated — fitting for an AI-tool
briefing. Speaker notes updated to match.

Co-Authored-By: Claude Opus 4.8 <noreply@anthropic.com>
Claude-Session: https://claude.ai/code/session_0142L4rKS2AV8rxQTDWMs7dy
</commit_message>
<xml_diff>
--- a/CostVision-Platform-Executive-Briefing.pptx
+++ b/CostVision-Platform-Executive-Briefing.pptx
@@ -2729,7 +2729,7 @@
           <a:p>
             <a:r>
               <a:rPr lang="en-US" dirty="0"/>
-              <a:t>I want to spend a moment on the effort behind this, because it speaks to how seriously we should take it as an asset. This is not a prototype, and it is emphatically not a thin wrapper around a chatbot. It's about seventy-five thousand lines of hand-written code — of which roughly fifty-eight thousand is core product logic — backed by nine hundred and seventeen automated tests across seventy-nine suites. The chart shows where that lives: a large front-end and 3D viewer, a sixteen-thousand-line deterministic cost engine that is the real IP — the auditable money maths for nineteen commodities and twenty regions — a full backend API, and a genuine Python geometry kernel running OCCT that reads STEP, IGES and STL files. Five different languages and runtimes working as one integrated system. Two takeaways for this room. First, the quality is engineered in — nearly ten thousand lines of tests mean it doesn't silently regress. Second, and this is the strategic point: this depth of engineering is precisely why the intelligence is a durable, proprietary asset we own — not a subscription someone else can switch off. We built real, defensible IP here.</a:t>
+              <a:t>I want to spend a moment on the effort behind this, because it speaks to how seriously we should take it as an asset. This is not a prototype, and it is emphatically not a thin wrapper around a chatbot. It's about seventy-five thousand lines of custom code — of which roughly fifty-eight thousand is core product logic — backed by nine hundred and seventeen automated tests across seventy-nine suites. I'll be transparent about how it was built, because it's actually part of the story: it was engineered in-house and accelerated with AI-assisted development — which is fitting, given what the tool itself does. The design, the domain knowledge, the cost models and the validation are ours; AI helped us build it faster. The chart shows where the code lives: a large front-end and 3D viewer, a sixteen-thousand-line deterministic cost engine that is the real IP — the auditable money maths for nineteen commodities and twenty regions — a full backend API, and a genuine Python geometry kernel running OCCT that reads STEP, IGES and STL files. Five languages and runtimes working as one integrated system. Two takeaways. First, the quality is engineered in — nearly ten thousand lines of tests mean it doesn't silently regress. Second, the strategic point: this depth of engineering, and the cost knowledge baked into it, is precisely why the intelligence is a durable, proprietary asset we own — not a subscription someone else can switch off.</a:t>
             </a:r>
             <a:endParaRPr lang="en-US" dirty="0"/>
           </a:p>
@@ -24470,8 +24470,8 @@
         </p:nvSpPr>
         <p:spPr>
           <a:xfrm>
-            <a:off x="548640" y="1536192"/>
-            <a:ext cx="11064240" cy="365760"/>
+            <a:off x="548640" y="1554480"/>
+            <a:ext cx="11064240" cy="320040"/>
           </a:xfrm>
           <a:prstGeom prst="rect">
             <a:avLst/>
@@ -24487,7 +24487,7 @@
               <a:buNone/>
             </a:pPr>
             <a:r>
-              <a:rPr lang="en-US" sz="1250" dirty="0">
+              <a:rPr lang="en-US" sz="1150" dirty="0">
                 <a:solidFill>
                   <a:srgbClr val="3E4C63"/>
                 </a:solidFill>
@@ -24495,9 +24495,9 @@
                 <a:ea typeface="Calibri" pitchFamily="34" charset="-122"/>
                 <a:cs typeface="Calibri" pitchFamily="34" charset="-120"/>
               </a:rPr>
-              <a:t>This is not a prototype or a thin wrapper around a chatbot. It is a substantial, tested, full-stack platform — built and owned in-house.</a:t>
-            </a:r>
-            <a:endParaRPr lang="en-US" sz="1250" dirty="0"/>
+              <a:t>Not a prototype or a thin wrapper around a chatbot — a substantial, tested, full-stack platform, custom-built in-house (AI-accelerated).</a:t>
+            </a:r>
+            <a:endParaRPr lang="en-US" sz="1150" dirty="0"/>
           </a:p>
         </p:txBody>
       </p:sp>
@@ -24630,7 +24630,7 @@
                 <a:ea typeface="Calibri" pitchFamily="34" charset="-122"/>
                 <a:cs typeface="Calibri" pitchFamily="34" charset="-120"/>
               </a:rPr>
-              <a:t>lines of code, hand-written</a:t>
+              <a:t>lines of custom code, built in-house</a:t>
             </a:r>
             <a:endParaRPr lang="en-US" sz="1000" dirty="0"/>
           </a:p>

</xml_diff>

<commit_message>
Executive Briefing: switch narration to first-person plural (we/our)
Convert all slide copy and speaker notes from second-person (you/your)
to first-person plural (we/our) for the in-house voice. Preserve object
case (us), keep the fixed phrase 'thank you', and hand-fix grammar the
mechanical pass would have broken.

Co-Authored-By: Claude Opus 4.8 <noreply@anthropic.com>
Claude-Session: https://claude.ai/code/session_0142L4rKS2AV8rxQTDWMs7dy
</commit_message>
<xml_diff>
--- a/CostVision-Platform-Executive-Briefing.pptx
+++ b/CostVision-Platform-Executive-Briefing.pptx
@@ -1674,7 +1674,7 @@
           <a:p>
             <a:r>
               <a:rPr lang="en-US" dirty="0"/>
-              <a:t>Welcome, and thank you for the time. What you're about to see is CostVision — our own AI cost-intelligence platform. Here's the one-line framing for today: we already do rigorous should-costing across every commodity — CostVision takes that same trusted method and automates the manual work with AI. Instead of selecting every input and keying geometry off the CAD and drawings by hand, it reads the model, suggests material and process for you to confirm, and returns a defensible, auditable should-cost in minutes. And unlike a static tool, it learns from every real quote. Today I'll walk the whole platform, go deep on CAD-to-Cost — where the automation is most visible — show the AI under the hood, and finish with how we'd roll it out alongside what we have and keep the data secure. Everything I show is from live runs — no mock-ups.</a:t>
+              <a:t>Welcome, and thank you for the time. What we're about to see is CostVision — our own AI cost-intelligence platform. Here's the one-line framing for today: we already do rigorous should-costing across every commodity — CostVision takes that same trusted method and automates the manual work with AI. Instead of selecting every input and keying geometry off the CAD and drawings by hand, it reads the model, suggests material and process for us to confirm, and returns a defensible, auditable should-cost in minutes. And unlike a static tool, it learns from every real quote. Today I'll walk the whole platform, go deep on CAD-to-Cost — where the automation is most visible — show the AI under the hood, and finish with how we'd roll it out alongside what we have and keep the data secure. Everything I show is from live runs — no mock-ups.</a:t>
             </a:r>
             <a:endParaRPr lang="en-US" dirty="0"/>
           </a:p>
@@ -1762,7 +1762,7 @@
           <a:p>
             <a:r>
               <a:rPr lang="en-US" dirty="0"/>
-              <a:t>Accuracy is the question senior teams always ask about AI, so let me be precise about how we earn it — it's engineered in layers. One: measured ground truth — the geometry kernel measures the part, so the AI is checked against physics, not trusted. Two: bounded sanity checks — if the AI's volume drifts more than twenty-five percent from the measured value it's flagged, over fifty percent it's rejected, and weight is cross-checked against density. Three, and this is the one I love telling engineers: the money maths is deterministic, and it reproduces a hand-calculated benchmark part — twenty-three pounds twenty-seven — to within one-hundredth of a percent. That's not a claim, it's a unit test. Four: provenance — every figure traces to its source with a confidence grade. Five: a confidence band, never a false single number. Six: it's been demonstrated on real automotive parts through the live system. I'll be straight with you — we don't quote a single headline 'X percent accurate on CAD' number, because honestly that depends on your parts and your rates, and we'd rather prove it on your data in the pilot. The box on the right is the takeaway: the AI can suggest, but it can never quietly decide the number. A wrong guess gets flagged, not baked into a quote.</a:t>
+              <a:t>Accuracy is the question senior teams always ask about AI, so let me be precise about how we earn it — it's engineered in layers. One: measured ground truth — the geometry kernel measures the part, so the AI is checked against physics, not trusted. Two: bounded sanity checks — if the AI's volume drifts more than twenty-five percent from the measured value it's flagged, over fifty percent it's rejected, and weight is cross-checked against density. Three, and this is the one I love telling engineers: the money maths is deterministic, and it reproduces a hand-calculated benchmark part — twenty-three pounds twenty-seven — to within one-hundredth of a percent. That's not a claim, it's a unit test. Four: provenance — every figure traces to its source with a confidence grade. Five: a confidence band, never a false single number. Six: it's been demonstrated on real automotive parts through the live system. and I'll be straight — we don't quote a single headline 'X percent accurate on CAD' number, because honestly that depends on our parts and our rates, and we'd rather prove it on our data in the pilot. The box on the right is the takeaway: the AI can suggest, but it can never quietly decide the number. A wrong guess gets flagged, not baked into a quote.</a:t>
             </a:r>
             <a:endParaRPr lang="en-US" dirty="0"/>
           </a:p>
@@ -1850,7 +1850,7 @@
           <a:p>
             <a:r>
               <a:rPr lang="en-US" dirty="0"/>
-              <a:t>Same philosophy, different input — electronics. Photograph a circuit board, and in about sixty seconds you get a costed, flagged bill of materials. The chart is a real result: the same automotive ECU, costed by an engineer bottom-up in half a day versus the AI from one photo — sixty-nine pounds against seventy-three, within about five percent, in a minute. On the right is what it delivers: a full BOM from the photo, an honest split between what's confirmed and what needs verifying, guardrails so a mis-read chip can't blow up the total, should-cost across regions, and it even infers the ISO 26262 safety class. There's a full deep-dive deck on just this feature if you want it — today it's one slide to show the platform isn't only about CAD.</a:t>
+              <a:t>Same philosophy, different input — electronics. Photograph a circuit board, and in about sixty seconds we get a costed, flagged bill of materials. The chart is a real result: the same automotive ECU, costed by an engineer bottom-up in half a day versus the AI from one photo — sixty-nine pounds against seventy-three, within about five percent, in a minute. On the right is what it delivers: a full BOM from the photo, an honest split between what's confirmed and what needs verifying, guardrails so a mis-read chip can't blow up the total, should-cost across regions, and it even infers the ISO 26262 safety class. There's a full deep-dive deck on just this feature if we want it — today it's one slide to show the platform isn't only about CAD.</a:t>
             </a:r>
             <a:endParaRPr lang="en-US" dirty="0"/>
           </a:p>
@@ -2026,7 +2026,7 @@
           <a:p>
             <a:r>
               <a:rPr lang="en-US" dirty="0"/>
-              <a:t>This is the engine behind 'the same part, priced anywhere.' It's four deterministic steps, no AI in the money. Step one: we take the base part cost — the eight-bucket breakdown, whether it came from CAD or a commodity form. Step two: we multiply through each region's real rate library — labour by trade, energy, material factors, machine rate, overhead, and the exchange rate. Step three: we add the landed pieces — packaging, logistics, duty, shipping. Step four: out comes a should-cost for every country, ranked, both ex-works and landed. And notice what you actually have to give it, bottom-left: the part once, the regions you care about, and a volume. Everything on the bottom-right is what the model factors in for you, per region — and on the next slide I'll show you those exact numbers, because transparency is the whole point.</a:t>
+              <a:t>This is the engine behind 'the same part, priced anywhere.' It's four deterministic steps, no AI in the money. Step one: we take the base part cost — the eight-bucket breakdown, whether it came from CAD or a commodity form. Step two: we multiply through each region's real rate library — labour by trade, energy, material factors, machine rate, overhead, and the exchange rate. Step three: we add the landed pieces — packaging, logistics, duty, shipping. Step four: out comes a should-cost for every country, ranked, both ex-works and landed. And notice what we actually have to give it, bottom-left: the part once, the regions we care about, and a volume. Everything on the bottom-right is what the model factors in for us, per region — and on the next slide we'll see those exact numbers, because transparency is the whole point.</a:t>
             </a:r>
             <a:endParaRPr lang="en-US" dirty="0"/>
           </a:p>
@@ -2114,7 +2114,7 @@
           <a:p>
             <a:r>
               <a:rPr lang="en-US" dirty="0"/>
-              <a:t>This is the slide that builds confidence, so let me slow right down. Everything the model uses is on the table — these are the real, current rates, not a mystery multiplier. Read across: a skilled operator is twenty-six pounds an hour in the UK, forty in Germany, but under eight in China and under four in Vietnam. Foundry labour, industrial electricity, and then the multipliers that capture machine cost, overhead structure and logistics distance. Germany's overhead runs ten percent above the UK; China's is twenty-five percent below; but China's logistics multiplier is one-point-four-five because the part has to travel. This is ten of the twenty regions — behind them sit material factors, exchange rates, gas, packaging and duty. The key message: it's one versioned library, used by every costing, fully auditable. When someone challenges a China number, you can show them exactly which rate drove it.</a:t>
+              <a:t>This is the slide that builds confidence, so let me slow right down. Everything the model uses is on the table — these are the real, current rates, not a mystery multiplier. Read across: a skilled operator is twenty-six pounds an hour in the UK, forty in Germany, but under eight in China and under four in Vietnam. Foundry labour, industrial electricity, and then the multipliers that capture machine cost, overhead structure and logistics distance. Germany's overhead runs ten percent above the UK; China's is twenty-five percent below; but China's logistics multiplier is one-point-four-five because the part has to travel. This is ten of the twenty regions — behind them sit material factors, exchange rates, gas, packaging and duty. The key message: it's one versioned library, used by every costing, fully auditable. When someone challenges a China number, we can show them exactly which rate drove it.</a:t>
             </a:r>
             <a:endParaRPr lang="en-US" dirty="0"/>
           </a:p>
@@ -2202,7 +2202,7 @@
           <a:p>
             <a:r>
               <a:rPr lang="en-US" dirty="0"/>
-              <a:t>This is the slide for anyone who says ‘your rates aren’t our rates.’ They don’t have to be. You can upload your own cost-rate database as one Excel workbook, and from that moment every costing runs on your numbers. Six categories, one tab each: materials with price per kilo and scrap recovery; the full machine-rate build-up that computes an hourly rate; fully-loaded labour by region and skill; energy; FX; and overhead and margin by commodity and tier. Who can do it? It’s admin-gated — an administrator uploads and can switch between your company rates and our built-in defaults, or reset; everyone else simply costs on whatever’s active, and a badge tells them which. The template is quick: download, fill, upload — and the server checks every row and rejects bad cells with a clear error, so you can’t silently corrupt the library. Every row is dated and carries a confidence flag. And updating is a single click: load a new dated rate set, activate it, and the whole portfolio re-prices — no re-keying. It’s versioned, so you can keep this-year versus last-year and see if an old scenario was costed on stale rates. Bottom line: your rates, validated, versioned and auditable, used everywhere.</a:t>
+              <a:t>This is the slide for anyone who says ‘our rates aren’t our rates.’ They don’t have to be. We can upload our own cost-rate database as one Excel workbook, and from that moment every costing runs on our numbers. Six categories, one tab each: materials with price per kilo and scrap recovery; the full machine-rate build-up that computes an hourly rate; fully-loaded labour by region and skill; energy; FX; and overhead and margin by commodity and tier. Who can do it? It’s admin-gated — an administrator uploads and can switch between our company rates and our built-in defaults, or reset; everyone else simply costs on whatever’s active, and a badge tells them which. The template is quick: download, fill, upload — and the server checks every row and rejects bad cells with a clear error, so we can’t silently corrupt the library. Every row is dated and carries a confidence flag. And updating is a single click: load a new dated rate set, activate it, and the whole portfolio re-prices — no re-keying. It’s versioned, so we can keep this-year versus last-year and see if an old scenario was costed on stale rates. Bottom line: our rates, validated, versioned and auditable, used everywhere.</a:t>
             </a:r>
             <a:endParaRPr lang="en-US" dirty="0"/>
           </a:p>
@@ -2290,7 +2290,7 @@
           <a:p>
             <a:r>
               <a:rPr lang="en-US" dirty="0"/>
-              <a:t>Let's make it concrete with a real part, priced by the real engine — a simple one-point-two kilo aluminium die-casting, ADC12, two cavities on an eight-hundred-tonne machine. Left chart, the UK cost stack: the total is six pounds ninety-six, and look — material is sixty-three percent of it. That tells a sourcing team instantly that this part is a material game, not a labour game. Right chart, the same part ex-works across regions: China at four-ninety-one is about twenty-three percent under the UK. But here's the sophistication your buyers will love — landed, once you add logistics and duty, that narrows to about twelve percent. The tool shows you both, so you don't chase a saving that shipping eats. And now the bit that fixes a real pain: you don't rebuild these should-costs by hand when your rates change. Material factors, labour, energy and overhead all live in one versioned rate library. Upload an updated, dated rate set once, and every part re-prices in a click. No more stale spreadsheets, no re-keying — the numbers reflect the latest rates you've loaded.</a:t>
+              <a:t>Let's make it concrete with a real part, priced by the real engine — a simple one-point-two kilo aluminium die-casting, ADC12, two cavities on an eight-hundred-tonne machine. Left chart, the UK cost stack: the total is six pounds ninety-six, and look — material is sixty-three percent of it. That tells a sourcing team instantly that this part is a material game, not a labour game. Right chart, the same part ex-works across regions: China at four-ninety-one is about twenty-three percent under the UK. But here's the sophistication our buyers will love — landed, once we add logistics and duty, that narrows to about twelve percent. The tool shows us both, so we don't chase a saving that shipping eats. And now the bit that fixes a real pain: we don't rebuild these should-costs by hand when our rates change. Material factors, labour, energy and overhead all live in one versioned rate library. Upload an updated, dated rate set once, and every part re-prices in a click. No more stale spreadsheets, no re-keying — the numbers reflect the latest rates we've loaded.</a:t>
             </a:r>
             <a:endParaRPr lang="en-US" dirty="0"/>
           </a:p>
@@ -2378,7 +2378,7 @@
           <a:p>
             <a:r>
               <a:rPr lang="en-US" dirty="0"/>
-              <a:t>This is where cost intelligence becomes money. A should-cost on its own is interesting; a should-cost that wins a negotiation is the product. Follow the flow: our should-cost on the left, drop in the supplier's quote, and the engine tears down the gap by driver — material, cycle time, rate, margin — then hands you a negotiation pack. The stats are illustrative but real in shape: quotes typically run about fifteen percent over should-cost, and on one part family that was ninety-one thousand pounds a year, with the single biggest lever — raw material — worth thirty-seven thousand. The pack gives you the gap table, the driver decomposition, the levers ranked by pounds, the exact questions to ask, and a one-click export. You stop arguing about the headline number and start negotiating the drivers. That's a winnable conversation.</a:t>
+              <a:t>This is where cost intelligence becomes money. A should-cost on its own is interesting; a should-cost that wins a negotiation is the product. Follow the flow: our should-cost on the left, drop in the supplier's quote, and the engine tears down the gap by driver — material, cycle time, rate, margin — then hands us a negotiation pack. The stats are illustrative but real in shape: quotes typically run about fifteen percent over should-cost, and on one part family that was ninety-one thousand pounds a year, with the single biggest lever — raw material — worth thirty-seven thousand. The pack gives us the gap table, the driver decomposition, the levers ranked by pounds, the exact questions to ask, and a one-click export. We stop arguing about the headline number and start negotiating the drivers. That's a winnable conversation.</a:t>
             </a:r>
             <a:endParaRPr lang="en-US" dirty="0"/>
           </a:p>
@@ -2466,7 +2466,7 @@
           <a:p>
             <a:r>
               <a:rPr lang="en-US" dirty="0"/>
-              <a:t>This is what makes CostVision more than a calculator — it's agentic. Four verbs, and they form a loop. It REMEMBERS every analysis as a case, shared across the team, so a junior inherits senior judgement on day one. It RECOGNISES a new part against that memory and shows why. It SELF-CORRECTS — log a real quote and it measures its own error, then corrects future estimates. And it ACTS — a background agent re-checks every part and flags overpayment by itself. The numbers are verified: error fell thirty-six-fold after learning from just three quotes; the agent surfaced half a million pounds a year, unattended; recognition hit ninety-nine percent. There's a dedicated deck on the agentic layer — today, this is the headline: the tool gets smarter every time you use it, and that intelligence is ours.</a:t>
+              <a:t>This is what makes CostVision more than a calculator — it's agentic. Four verbs, and they form a loop. It REMEMBERS every analysis as a case, shared across the team, so a junior inherits senior judgement on day one. It RECOGNISES a new part against that memory and shows why. It SELF-CORRECTS — log a real quote and it measures its own error, then corrects future estimates. And it ACTS — a background agent re-checks every part and flags overpayment by itself. The numbers are verified: error fell thirty-six-fold after learning from just three quotes; the agent surfaced half a million pounds a year, unattended; recognition hit ninety-nine percent. There's a dedicated deck on the agentic layer — today, this is the headline: the tool gets smarter every time we use it, and that intelligence is ours.</a:t>
             </a:r>
             <a:endParaRPr lang="en-US" dirty="0"/>
           </a:p>
@@ -2554,7 +2554,7 @@
           <a:p>
             <a:r>
               <a:rPr lang="en-US" dirty="0"/>
-              <a:t>Four newer capabilities that lift this above a normal estimator. Conformal confidence bands — instead of asserting a precision, it states an observed fact with a statistical guarantee: ninety percent of your real quotes landed within plus-or-minus six-and-a-half percent. That's evidence a buyer can defend. The causal coach knows WHY a part costs what it does and writes the negotiating sentence for you — every one percent move in aluminium shifts the price by eleven pence. The what-if engine lets you move a commodity and watch the price recompute, for one part or the whole portfolio, so sourcing gets ahead of the market. And carbon co-costing puts a CO2 figure next to every pound, which customers increasingly demand. Each of these turns a number into a decision.</a:t>
+              <a:t>Four newer capabilities that lift this above a normal estimator. Conformal confidence bands — instead of asserting a precision, it states an observed fact with a statistical guarantee: ninety percent of our real quotes landed within plus-or-minus six-and-a-half percent. That's evidence a buyer can defend. The causal coach knows WHY a part costs what it does and writes the negotiating sentence for us — every one percent move in aluminium shifts the price by eleven pence. The what-if engine lets us move a commodity and watch the price recompute, for one part or the whole portfolio, so sourcing gets ahead of the market. And carbon co-costing puts a CO2 figure next to every pound, which customers increasingly demand. Each of these turns a number into a decision.</a:t>
             </a:r>
             <a:endParaRPr lang="en-US" dirty="0"/>
           </a:p>
@@ -2642,7 +2642,7 @@
           <a:p>
             <a:r>
               <a:rPr lang="en-US" dirty="0"/>
-              <a:t>Before we dive in, here's the entire story on one page — if you only take away this slide, you'll have the gist. Keep the framing in mind: this is our proven should-cost method, automated and made intelligent. Five numbers up top: it costs a part in minutes, not the hours of manual setup we spend today; it carries nineteen commodity engines and twenty real-rate regions; in a live test it landed within about five percent of a hand-built estimate; and the autonomous agent found half a million pounds a year with nobody at the keyboard. Underneath: what it is — one platform that reads any input, prices it globally, hands you the negotiation, and learns as it goes. The four boxes are the four jobs it does. And the bottom line for this room: faster quotes, better margins, one consistent number, and an intelligence asset that's ours and compounds. Everything after this is detail and proof.</a:t>
+              <a:t>Before we dive in, here's the entire story on one page — if we only take away this slide, we'll have the gist. Keep the framing in mind: this is our proven should-cost method, automated and made intelligent. Five numbers up top: it costs a part in minutes, not the hours of manual setup we spend today; it carries nineteen commodity engines and twenty real-rate regions; in a live test it landed within about five percent of a hand-built estimate; and the autonomous agent found half a million pounds a year with nobody at the keyboard. Underneath: what it is — one platform that reads any input, prices it globally, hands us the negotiation, and learns as it goes. The four boxes are the four jobs it does. And the bottom line for this room: faster quotes, better margins, one consistent number, and an intelligence asset that's ours and compounds. Everything after this is detail and proof.</a:t>
             </a:r>
             <a:endParaRPr lang="en-US" dirty="0"/>
           </a:p>
@@ -2730,7 +2730,7 @@
           <a:p>
             <a:r>
               <a:rPr lang="en-US" dirty="0"/>
-              <a:t>Whenever AI touches money, the honest question is 'can I trust it?' — so let me answer it head-on. First, it's glass-box: every learned or derived number stays auditable, a value an engineer can read and defend. The AI narrates and explains; it never sets the price in secret. Second, accuracy is measured — against real geometry and real quotes — and reported openly, before and after. Third, it's honest about uncertainty: confidence bands and clear flags, never a false single number. And fourth, it's production-grade: nine hundred and seventeen automated tests, exercised on the live system. The through-line of the entire platform is on that green bar: AI does the understanding, deterministic maths does the money, every number is traceable and tested. That's what lets you put a CostVision number in front of a supplier — or in front of this board.</a:t>
+              <a:t>Whenever AI touches money, the honest question is 'can I trust it?' — so let me answer it head-on. First, it's glass-box: every learned or derived number stays auditable, a value an engineer can read and defend. The AI narrates and explains; it never sets the price in secret. Second, accuracy is measured — against real geometry and real quotes — and reported openly, before and after. Third, it's honest about uncertainty: confidence bands and clear flags, never a false single number. And fourth, it's production-grade: nine hundred and seventeen automated tests, exercised on the live system. The through-line of the entire platform is on that green bar: AI does the understanding, deterministic maths does the money, every number is traceable and tested. That's what lets us put a CostVision number in front of a supplier — or in front of this board.</a:t>
             </a:r>
             <a:endParaRPr lang="en-US" dirty="0"/>
           </a:p>
@@ -3082,7 +3082,7 @@
           <a:p>
             <a:r>
               <a:rPr lang="en-US" dirty="0"/>
-              <a:t>For a room like this, security isn't a footnote — so here it is head-on, and precisely. CostVision runs on-premise: the knowledge base and every analysis are stored on our own servers, and no vendor ever retains our data. Let me be exact about what does leave the building, because someone will ask: the only thing that goes out is the AI inference request itself — the prompt for a given analysis — and it goes through our own server to the model endpoint, where it is not retained. For the most sensitive programmes we can route that privately or run fully air-gapped, and then nothing leaves at all — the deterministic core still works. The key lives server-side; the browser never sees it. Every number carries provenance and is logged, so it's auditable. And critically, the accumulated intelligence is OUR IP — it doesn't walk out with a subscription. Your data, your infrastructure, your IP.</a:t>
+              <a:t>For a room like this, security isn't a footnote — so here it is head-on, and precisely. CostVision runs on-premise: the knowledge base and every analysis are stored on our own servers, and no vendor ever retains our data. Let me be exact about what does leave the building, because someone will ask: the only thing that goes out is the AI inference request itself — the prompt for a given analysis — and it goes through our own server to the model endpoint, where it is not retained. For the most sensitive programmes we can route that privately or run fully air-gapped, and then nothing leaves at all — the deterministic core still works. The key lives server-side; the browser never sees it. Every number carries provenance and is logged, so it's auditable. And critically, the accumulated intelligence is OUR IP — it doesn't walk out with a subscription. Our data, our infrastructure, our IP.</a:t>
             </a:r>
             <a:endParaRPr lang="en-US" dirty="0"/>
           </a:p>
@@ -3170,7 +3170,7 @@
           <a:p>
             <a:r>
               <a:rPr lang="en-US" dirty="0"/>
-              <a:t>Here's my runbook for the live demo — and if I'm short on time I'll do steps one, three and six. I'll start with CAD-to-Cost: upload a STEP model, show the 3D viewer and the feature table so you see it's reading real geometry, then hit Calculate — the should-cost and confidence band come back in under a minute. Then I'll attach a 2D drawing and re-run, so you watch the tolerances tighten the estimate live. Step three, I'll switch regions and show the twenty-country spread in one click — China against Germany. Then something different — I'll drop a photo of a circuit board and watch a full BOM build itself. Step five, I'll paste in a supplier quote and generate the negotiation pack. And I'll finish on the agent's findings panel — half a million pounds it found on its own. That's the note to end on. The checklist on the right is what I've got staged so nothing stalls — including cached runs as a fallback if the network is slow.</a:t>
+              <a:t>Here's my runbook for the live demo — and if I'm short on time I'll do steps one, three and six. I'll start with CAD-to-Cost: upload a STEP model, show the 3D viewer and the feature table so we see it's reading real geometry, then hit Calculate — the should-cost and confidence band come back in under a minute. Then I'll attach a 2D drawing and re-run, so we watch the tolerances tighten the estimate live. Step three, I'll switch regions and show the twenty-country spread in one click — China against Germany. Then something different — I'll drop a photo of a circuit board and watch a full BOM build itself. Step five, I'll paste in a supplier quote and generate the negotiation pack. And I'll finish on the agent's findings panel — half a million pounds it found on its own. That's the note to end on. The checklist on the right is what I've got staged so nothing stalls — including cached runs as a fallback if the network is slow.</a:t>
             </a:r>
             <a:endParaRPr lang="en-US" dirty="0"/>
           </a:p>
@@ -3258,7 +3258,7 @@
           <a:p>
             <a:r>
               <a:rPr lang="en-US" dirty="0"/>
-              <a:t>Let me bring it home. Any input in — a CAD model, a photo, a description — and a defensible, self-improving should-cost out. Fast, explainable, self-improving, secure, and entirely ours. If you're persuaded, the ask is three small, low-risk decisions: approve a six-week on-premise pilot and let us seed it with our historic quotes; pick a first part family — a CAD part, a board, or a live RFQ — for us to cost; and put the agent's monthly findings on the sourcing agenda, because it's already finding money. Do those three things and we start compounding value from day one. Thank you — I'm happy to take questions, or better yet, let's open the live system and cost something of yours right now.</a:t>
+              <a:t>Let me bring it home. Any input in — a CAD model, a photo, a description — and a defensible, self-improving should-cost out. Fast, explainable, self-improving, secure, and entirely ours. If we're persuaded, the ask is three small, low-risk decisions: approve a six-week on-premise pilot and let us seed it with our historic quotes; pick a first part family — a CAD part, a board, or a live RFQ — for us to cost; and put the agent's monthly findings on the sourcing agenda, because it's already finding money. Do those three things and we start compounding value from day one. Thank you — I'm happy to take questions, or better yet, let's open the live system and cost something of ours right now.</a:t>
             </a:r>
             <a:endParaRPr lang="en-US" dirty="0"/>
           </a:p>
@@ -3346,7 +3346,7 @@
           <a:p>
             <a:r>
               <a:rPr lang="en-US" dirty="0"/>
-              <a:t>Here's the shape of the next thirty minutes, and a one-paragraph 'why' before we dive in. Let me set the framing carefully, because it matters: we already do proper should-costing. We have an internal tool that covers every commodity with a rigorous, bottom-up method — that's a real asset and it works. The one thing it asks of us is a lot of manual effort: selecting every input and reading the geometry off the CAD and drawings by hand, part by part. So this isn't a story about a broken system — it's about taking that same trusted method and automating the hands-on parts with AI. I'll start there, then give you the whole platform on one slide, go deep on CAD-to-Cost where the automation is most visible, tour the other capabilities, and close on trust, security and how we'd roll it out alongside what we have today. Jump in any time.</a:t>
+              <a:t>Here's the shape of the next thirty minutes, and a one-paragraph 'why' before we dive in. Let me set the framing carefully, because it matters: we already do proper should-costing. We have an internal tool that covers every commodity with a rigorous, bottom-up method — that's a real asset and it works. The one thing it asks of us is a lot of manual effort: selecting every input and reading the geometry off the CAD and drawings by hand, part by part. So this isn't a story about a broken system — it's about taking that same trusted method and automating the hands-on parts with AI. I'll start there, then lay out the whole platform on one slide, go deep on CAD-to-Cost where the automation is most visible, tour the other capabilities, and close on trust, security and how we'd roll it out alongside what we have today. Jump in any time.</a:t>
             </a:r>
             <a:endParaRPr lang="en-US" dirty="0"/>
           </a:p>
@@ -3434,7 +3434,7 @@
           <a:p>
             <a:r>
               <a:rPr lang="en-US" dirty="0"/>
-              <a:t>I want to be clear up front: we're not fixing something broken. Our internal should-cost tool is genuinely good — it's thorough, it's bottom-up, and it covers every commodity. The team has built real rigour into it. The honest observation is simply that it's hands-on: for every part you select the material, the process, the machine, and you key in the geometry and tolerances by hand from the 3D CAD and the drawings — the classic should-costing method. And when economics move, someone updates the rates manually. CostVision doesn't throw any of that away. It keeps the exact same defensible method — and automates the hands-on parts with AI: it reads the CAD and the drawings for you, it suggests the material and process with a confidence score you confirm, and it keeps the rates current on its own. So the shift isn't 'old versus new' — it's the same trusted should-cost, with the manual effort taken out, so our experts spend their time on judgement and decisions instead of data entry. That's the whole story of this deck.</a:t>
+              <a:t>I want to be clear up front: we're not fixing something broken. Our internal should-cost tool is genuinely good — it's thorough, it's bottom-up, and it covers every commodity. The team has built real rigour into it. The honest observation is simply that it's hands-on: for every part we select the material, the process, the machine, and we key in the geometry and tolerances by hand from the 3D CAD and the drawings — the classic should-costing method. And when economics move, someone updates the rates manually. CostVision doesn't throw any of that away. It keeps the exact same defensible method — and automates the hands-on parts with AI: it reads the CAD and the drawings for us, it suggests the material and process with a confidence score we confirm, and it keeps the rates current on its own. So the shift isn't 'old versus new' — it's the same trusted should-cost, with the manual effort taken out, so our experts spend their time on judgement and decisions instead of data entry. That's the whole story of this deck.</a:t>
             </a:r>
             <a:endParaRPr lang="en-US" dirty="0"/>
           </a:p>
@@ -3522,7 +3522,7 @@
           <a:p>
             <a:r>
               <a:rPr lang="en-US" dirty="0"/>
-              <a:t>This is the whole platform on one slide, and I'd ask you to remember the shape: four columns, left to right. On the left, inputs — and notice how forgiving they are: a CAD model, a photo, a sentence, an RFQ, whatever you have. Next, the AI layer: it reads and understands that input — the vision models, the reasoning, the memory. Then the crucial column — deterministic engines. This is where the money maths happens, and there is no AI in it. Nineteen commodity engines, real country rates, feature-based costing. And on the right, outputs: a full breakdown, a confidence range, a negotiation pack, exports, even a carbon figure. The golden rule at the bottom is the one to internalise: the AI understands the input, but it never sets the price. Every pound is auditable arithmetic. That's what makes this defensible.</a:t>
+              <a:t>This is the whole platform on one slide, and I'd ask us all to remember the shape: four columns, left to right. On the left, inputs — and notice how forgiving they are: a CAD model, a photo, a sentence, an RFQ, whatever we have. Next, the AI layer: it reads and understands that input — the vision models, the reasoning, the memory. Then the crucial column — deterministic engines. This is where the money maths happens, and there is no AI in it. Nineteen commodity engines, real country rates, feature-based costing. And on the right, outputs: a full breakdown, a confidence range, a negotiation pack, exports, even a carbon figure. The golden rule at the bottom is the one to internalise: the AI understands the input, but it never sets the price. Every pound is auditable arithmetic. That's what makes this defensible.</a:t>
             </a:r>
             <a:endParaRPr lang="en-US" dirty="0"/>
           </a:p>
@@ -3610,7 +3610,7 @@
           <a:p>
             <a:r>
               <a:rPr lang="en-US" dirty="0"/>
-              <a:t>If someone asks 'what does CostVision actually do,' this is the answer — four jobs. It ESTIMATES: from a CAD model, a board photo, or any of nineteen commodity engines. It UNDERSTANDS: the 3D viewer with B-rep intelligence, the feature table, the assistant that answers from our own data. It helps you DECIDE and NEGOTIATE: should-cost across twenty regions, what-if scenarios, and a coach that hands you the argument. And it LEARNS and stays GOVERNED: it remembers, self-corrects, hunts for savings on its own — and every number is auditable and stays inside our walls. I'll spend most of today in the first two columns, because that's where the demo lives, but keep this map in mind — it's the whole surface area.</a:t>
+              <a:t>If someone asks 'what does CostVision actually do,' this is the answer — four jobs. It ESTIMATES: from a CAD model, a board photo, or any of nineteen commodity engines. It UNDERSTANDS: the 3D viewer with B-rep intelligence, the feature table, the assistant that answers from our own data. It helps us DECIDE and NEGOTIATE: should-cost across twenty regions, what-if scenarios, and a coach that hands us the argument. And it LEARNS and stays GOVERNED: it remembers, self-corrects, hunts for savings on its own — and every number is auditable and stays inside our walls. I'll spend most of today in the first two columns, because that's where the demo lives, but keep this map in mind — it's the whole surface area.</a:t>
             </a:r>
             <a:endParaRPr lang="en-US" dirty="0"/>
           </a:p>
@@ -3698,7 +3698,7 @@
           <a:p>
             <a:r>
               <a:rPr lang="en-US" dirty="0"/>
-              <a:t>Now the heart of the demo — CAD-to-Cost — and this is exactly where the manual effort lives today. In our current method, an engineer opens the CAD, measures it, reads the tolerances off the drawing, and keys all of that in before selecting a process. CostVision does those steps for you. The promise is simple: drop in a 3D model, get a should-cost. But how it does that is what earns trust. Four moves, left to right. First, it reads the REAL geometry — we run a genuine geometry kernel that measures volume, bounding box and surface area. That's measured ground truth, not the AI guessing. Second, it recognises the manufacturing features — the holes, pockets, slots, bends — and turns them into actual machining operations. Third, the AI proposes a material and a process route, each with a confidence score, and you can override. Fourth, a deterministic engine prices it and explains the number with a confidence band and design-for-manufacture guidance. And note the bottom line — a 3D model alone is enough to get a defensible number, and if you attach the 2D drawing it reads the tolerances and GD&amp;T to sharpen the estimate further. The more you give it, the tighter the answer.</a:t>
+              <a:t>Now the heart of the demo — CAD-to-Cost — and this is exactly where the manual effort lives today. In our current method, an engineer opens the CAD, measures it, reads the tolerances off the drawing, and keys all of that in before selecting a process. CostVision does those steps for us. The promise is simple: drop in a 3D model, get a should-cost. But how it does that is what earns trust. Four moves, left to right. First, it reads the REAL geometry — we run a genuine geometry kernel that measures volume, bounding box and surface area. That's measured ground truth, not the AI guessing. Second, it recognises the manufacturing features — the holes, pockets, slots, bends — and turns them into actual machining operations. Third, the AI proposes a material and a process route, each with a confidence score, and we can override. Fourth, a deterministic engine prices it and explains the number with a confidence band and design-for-manufacture guidance. And note the bottom line — a 3D model alone is enough to get a defensible number, and if we attach the 2D drawing it reads the tolerances and GD&amp;T to sharpen the estimate further. The more we give it, the tighter the answer.</a:t>
             </a:r>
             <a:endParaRPr lang="en-US" dirty="0"/>
           </a:p>
@@ -3786,7 +3786,7 @@
           <a:p>
             <a:r>
               <a:rPr lang="en-US" dirty="0"/>
-              <a:t>Here's the pipeline end to end — follow it left to right. You upload the model. The geometry engine measures it — real volume, bounding box, surface area, faces. Feature recognition finds the holes, pockets, slots and bends. The AI suggests a material and process, with a confidence score. The deterministic engine prices material, machining and non-recurring cost. Then — and this is the step I want you to remember — a sanity check compares every AI-suggested number against the measured geometry. Finally you get a full should-cost with a confidence band and provenance on every line. The colour split matters: purple is where AI understands the model; green is where deterministic maths sets the price. And the safety net at the bottom is the whole game — because we have measured ground truth, a hallucinated dimension gets flagged, not silently priced. That's what makes a CAD estimate you can actually defend.</a:t>
+              <a:t>Here's the pipeline end to end — follow it left to right. We upload the model. The geometry engine measures it — real volume, bounding box, surface area, faces. Feature recognition finds the holes, pockets, slots and bends. The AI suggests a material and process, with a confidence score. The deterministic engine prices material, machining and non-recurring cost. Then — and this is the step I want us to remember — a sanity check compares every AI-suggested number against the measured geometry. Finally we get a full should-cost with a confidence band and provenance on every line. The colour split matters: purple is where AI understands the model; green is where deterministic maths sets the price. And the safety net at the bottom is the whole game — because we have measured ground truth, a hallucinated dimension gets flagged, not silently priced. That's what makes a CAD estimate we can actually defend.</a:t>
             </a:r>
             <a:endParaRPr lang="en-US" dirty="0"/>
           </a:p>
@@ -3874,7 +3874,7 @@
           <a:p>
             <a:r>
               <a:rPr lang="en-US" dirty="0"/>
-              <a:t>This is the AI intelligence layered on top of the geometry — the part that makes engineers lean in. Start top-left: a real interactive 3D viewer in the browser — rotate, section, measure, and the highlights link a face on the model to a line in the cost. Underneath that: B-rep face intelligence. This matters — it understands the boundary representation, the actual faces and edges and how they relate, not just a mesh of triangles. That's what lets it recognise a pocket as a pocket. The feature table lists every detected feature and feeds it straight into the costing as a real operation — no manual keying. Feature-based machining then costs each secondary operation per feature and per commodity. The AI suggests material and process with a confidence score you can override. And the manufacturability score tells the designer what's driving cost — so this isn't just an estimate, it's design feedback.</a:t>
+              <a:t>This is the AI intelligence layered on top of the geometry — the part that makes engineers lean in. Start top-left: a real interactive 3D viewer in the browser — rotate, section, measure, and the highlights link a face on the model to a line in the cost. Underneath that: B-rep face intelligence. This matters — it understands the boundary representation, the actual faces and edges and how they relate, not just a mesh of triangles. That's what lets it recognise a pocket as a pocket. The feature table lists every detected feature and feeds it straight into the costing as a real operation — no manual keying. Feature-based machining then costs each secondary operation per feature and per commodity. The AI suggests material and process with a confidence score we can override. And the manufacturability score tells the designer what's driving cost — so this isn't just an estimate, it's design feedback.</a:t>
             </a:r>
             <a:endParaRPr lang="en-US" dirty="0"/>
           </a:p>
@@ -6353,7 +6353,7 @@
                 <a:ea typeface="Calibri" pitchFamily="34" charset="-122"/>
                 <a:cs typeface="Calibri" pitchFamily="34" charset="-120"/>
               </a:rPr>
-              <a:t>Because the geometry is measured and the maths is deterministic, a wrong guess gets caught and flagged, not baked into a quote. That is the difference between a demo and a number you can put in front of a supplier.</a:t>
+              <a:t>Because the geometry is measured and the maths is deterministic, a wrong guess gets caught and flagged, not baked into a quote. That is the difference between a demo and a number we can put in front of a supplier.</a:t>
             </a:r>
             <a:endParaRPr lang="en-US" sz="1150" dirty="0"/>
           </a:p>
@@ -7144,7 +7144,7 @@
                 <a:ea typeface="Calibri" pitchFamily="34" charset="-122"/>
                 <a:cs typeface="Calibri" pitchFamily="34" charset="-120"/>
               </a:rPr>
-              <a:t>headline splits the £ you can trust from the £ to firm up</a:t>
+              <a:t>headline splits the £ we can trust from the £ to firm up</a:t>
             </a:r>
             <a:endParaRPr lang="en-US" sz="1030" dirty="0"/>
           </a:p>
@@ -10982,7 +10982,7 @@
                 <a:ea typeface="Calibri" pitchFamily="34" charset="-122"/>
                 <a:cs typeface="Calibri" pitchFamily="34" charset="-120"/>
               </a:rPr>
-              <a:t>What you give it</a:t>
+              <a:t>What we give it</a:t>
             </a:r>
             <a:endParaRPr lang="en-US" sz="1350" dirty="0"/>
           </a:p>
@@ -15948,7 +15948,7 @@
                 <a:ea typeface="Calibri" pitchFamily="34" charset="-122"/>
                 <a:cs typeface="Calibri" pitchFamily="34" charset="-120"/>
               </a:rPr>
-              <a:t>Bring your own rate database — your rates, your numbers</a:t>
+              <a:t>Bring our own rate database — our rates, our numbers</a:t>
             </a:r>
             <a:endParaRPr lang="en-US" sz="2400" dirty="0"/>
           </a:p>
@@ -16010,7 +16010,7 @@
                 <a:ea typeface="Calibri" pitchFamily="34" charset="-122"/>
                 <a:cs typeface="Calibri" pitchFamily="34" charset="-120"/>
               </a:rPr>
-              <a:t>Upload your organisation’s own cost rates as one Excel workbook. Every costing then runs on your numbers — validated on upload, versioned, and fully auditable. No black box, no lock-in to our defaults.</a:t>
+              <a:t>Upload our organisation’s own cost rates as one Excel workbook. Every costing then runs on our numbers — validated on upload, versioned, and fully auditable. No black box, no lock-in to our defaults.</a:t>
             </a:r>
             <a:endParaRPr lang="en-US" sz="1200" dirty="0"/>
           </a:p>
@@ -17400,7 +17400,7 @@
                 <a:ea typeface="Calibri" pitchFamily="34" charset="-122"/>
                 <a:cs typeface="Calibri" pitchFamily="34" charset="-120"/>
               </a:rPr>
-              <a:t>, so you keep current vs old vintages and scenarios flag if costed on an older version.</a:t>
+              <a:t>, so we keep current vs old vintages and scenarios flag if costed on an older version.</a:t>
             </a:r>
             <a:endParaRPr lang="en-US" sz="960" dirty="0"/>
           </a:p>
@@ -17489,7 +17489,7 @@
                 <a:ea typeface="Calibri" pitchFamily="34" charset="-122"/>
                 <a:cs typeface="Calibri" pitchFamily="34" charset="-120"/>
               </a:rPr>
-              <a:t>Your rates, your defensible numbers.  </a:t>
+              <a:t>Our rates, our defensible numbers.  </a:t>
             </a:r>
             <a:pPr indent="0" marL="0">
               <a:lnSpc>
@@ -20119,7 +20119,7 @@
                 <a:ea typeface="Calibri" pitchFamily="34" charset="-122"/>
                 <a:cs typeface="Calibri" pitchFamily="34" charset="-120"/>
               </a:rPr>
-              <a:t>Illustrative figures — the same teardown runs on your real supplier quotes.</a:t>
+              <a:t>Illustrative figures — the same teardown runs on our real supplier quotes.</a:t>
             </a:r>
             <a:endParaRPr lang="en-US" sz="850" dirty="0"/>
           </a:p>
@@ -20225,7 +20225,7 @@
                 <a:ea typeface="Calibri" pitchFamily="34" charset="-122"/>
                 <a:cs typeface="Calibri" pitchFamily="34" charset="-120"/>
               </a:rPr>
-              <a:t>a line-by-line gap table, cost-driver decomposition (which parameter drives each gap), recovery levers ranked by £/yr, ready-to-send supplier questions, and a one-click PDF &amp; PowerPoint. You stop arguing about the total and start negotiating the drivers.</a:t>
+              <a:t>a line-by-line gap table, cost-driver decomposition (which parameter drives each gap), recovery levers ranked by £/yr, ready-to-send supplier questions, and a one-click PDF &amp; PowerPoint. We stop arguing about the total and start negotiating the drivers.</a:t>
             </a:r>
             <a:endParaRPr lang="en-US" sz="1150" dirty="0"/>
           </a:p>
@@ -22421,7 +22421,7 @@
                 <a:ea typeface="Calibri" pitchFamily="34" charset="-122"/>
                 <a:cs typeface="Calibri" pitchFamily="34" charset="-120"/>
               </a:rPr>
-              <a:t>A statistically-guaranteed range proven against your own logged quotes — "90% land within ±6.5%", evidence not assertion.</a:t>
+              <a:t>A statistically-guaranteed range proven against our own logged quotes — "90% land within ±6.5%", evidence not assertion.</a:t>
             </a:r>
             <a:endParaRPr lang="en-US" sz="1100" dirty="0"/>
           </a:p>
@@ -24220,7 +24220,7 @@
                 <a:ea typeface="Calibri" pitchFamily="34" charset="-122"/>
                 <a:cs typeface="Calibri" pitchFamily="34" charset="-120"/>
               </a:rPr>
-              <a:t>one AI platform that turns any engineering input — a CAD model, a board photo, a description — into a defensible, auditable should-cost in minutes, prices it across 20 regions, hands you the negotiation, and learns from every real quote. AI understands the input; deterministic maths sets every price.</a:t>
+              <a:t>one AI platform that turns any engineering input — a CAD model, a board photo, a description — into a defensible, auditable should-cost in minutes, prices it across 20 regions, hands us the negotiation, and learns from every real quote. AI understands the input; deterministic maths sets every price.</a:t>
             </a:r>
             <a:endParaRPr lang="en-US" sz="1250" dirty="0"/>
           </a:p>
@@ -26083,7 +26083,7 @@
                 <a:ea typeface="Calibri" pitchFamily="34" charset="-122"/>
                 <a:cs typeface="Calibri" pitchFamily="34" charset="-120"/>
               </a:rPr>
-              <a:t>the AI does the understanding; deterministic maths does the money; and every number is traceable, bounded and testable. That is what lets you put a CostVision number in front of a supplier — or a board.</a:t>
+              <a:t>the AI does the understanding; deterministic maths does the money; and every number is traceable, bounded and testable. That is what lets us put a CostVision number in front of a supplier — or a board.</a:t>
             </a:r>
             <a:endParaRPr lang="en-US" sz="1200" dirty="0"/>
           </a:p>
@@ -28499,7 +28499,7 @@
                 <a:ea typeface="Calibri" pitchFamily="34" charset="-122"/>
                 <a:cs typeface="Calibri" pitchFamily="34" charset="-120"/>
               </a:rPr>
-              <a:t>Line-level should-cost lets you challenge every quote by driver — the agent alone surfaced ~£512k/yr in a demo.</a:t>
+              <a:t>Line-level should-cost lets us challenge every quote by driver — the agent alone surfaced ~£512k/yr in a demo.</a:t>
             </a:r>
             <a:endParaRPr lang="en-US" sz="1150" dirty="0"/>
           </a:p>
@@ -31563,7 +31563,7 @@
                 <a:ea typeface="Calibri" pitchFamily="34" charset="-122"/>
                 <a:cs typeface="Calibri" pitchFamily="34" charset="-120"/>
               </a:rPr>
-              <a:t>Built for enterprise from the ground up — your data, your infrastructure, your IP.</a:t>
+              <a:t>Built for enterprise from the ground up — our data, our infrastructure, our IP.</a:t>
             </a:r>
             <a:endParaRPr lang="en-US" sz="1250" dirty="0"/>
           </a:p>
@@ -32851,7 +32851,7 @@
                 <a:ea typeface="Calibri" pitchFamily="34" charset="-122"/>
                 <a:cs typeface="Calibri" pitchFamily="34" charset="-120"/>
               </a:rPr>
-              <a:t>only the AI inference request, sent via our own server and not retained by the model provider — and in air-gapped / private-routing mode, not even that. Your data, your infrastructure, your IP.</a:t>
+              <a:t>only the AI inference request, sent via our own server and not retained by the model provider — and in air-gapped / private-routing mode, not even that. Our data, our infrastructure, our IP.</a:t>
             </a:r>
             <a:endParaRPr lang="en-US" sz="1050" dirty="0"/>
           </a:p>
@@ -34753,7 +34753,7 @@
                 <a:ea typeface="Calibri" pitchFamily="34" charset="-122"/>
                 <a:cs typeface="Calibri" pitchFamily="34" charset="-120"/>
               </a:rPr>
-              <a:t>Before you start</a:t>
+              <a:t>Before we start</a:t>
             </a:r>
             <a:endParaRPr lang="en-US" sz="1300" dirty="0"/>
           </a:p>
@@ -39200,7 +39200,7 @@
                 <a:ea typeface="Calibri" pitchFamily="34" charset="-122"/>
                 <a:cs typeface="Calibri" pitchFamily="34" charset="-120"/>
               </a:rPr>
-              <a:t>the deterministic method you trust — the manual steps removed</a:t>
+              <a:t>the deterministic method we trust — the manual steps removed</a:t>
             </a:r>
             <a:endParaRPr lang="en-US" sz="1000" dirty="0"/>
           </a:p>
@@ -39435,7 +39435,7 @@
                 <a:ea typeface="Calibri" pitchFamily="34" charset="-122"/>
                 <a:cs typeface="Calibri" pitchFamily="34" charset="-120"/>
               </a:rPr>
-              <a:t>AI suggests, you decide</a:t>
+              <a:t>AI suggests, we decide</a:t>
             </a:r>
             <a:endParaRPr lang="en-US" sz="1250" dirty="0"/>
           </a:p>
@@ -39730,7 +39730,7 @@
                 <a:ea typeface="Calibri" pitchFamily="34" charset="-122"/>
                 <a:cs typeface="Calibri" pitchFamily="34" charset="-120"/>
               </a:rPr>
-              <a:t>the same defensible should-cost, with the manual work automated and AI-assisted — so your experts spend their time on decisions, not data entry.</a:t>
+              <a:t>the same defensible should-cost, with the manual work automated and AI-assisted — so our experts spend their time on decisions, not data entry.</a:t>
             </a:r>
             <a:endParaRPr lang="en-US" sz="1200" dirty="0"/>
           </a:p>
@@ -40130,7 +40130,7 @@
                 <a:ea typeface="Calibri" pitchFamily="34" charset="-122"/>
                 <a:cs typeface="Calibri" pitchFamily="34" charset="-120"/>
               </a:rPr>
-              <a:t>Any engineering input → AI understands it → deterministic engines price it → you get a defensible, negotiation-ready result.</a:t>
+              <a:t>Any engineering input → AI understands it → deterministic engines price it → we get a defensible, negotiation-ready result.</a:t>
             </a:r>
             <a:endParaRPr lang="en-US" sz="1250" dirty="0"/>
           </a:p>
@@ -42071,7 +42071,7 @@
                 <a:ea typeface="Calibri" pitchFamily="34" charset="-122"/>
                 <a:cs typeface="Calibri" pitchFamily="34" charset="-120"/>
               </a:rPr>
-              <a:t>AI only ever understands the input. It never sets the price — every pound is deterministic, auditable arithmetic you can trace and defend.</a:t>
+              <a:t>AI only ever understands the input. It never sets the price — every pound is deterministic, auditable arithmetic we can trace and defend.</a:t>
             </a:r>
             <a:endParaRPr lang="en-US" sz="1200" dirty="0"/>
           </a:p>
@@ -44978,7 +44978,7 @@
                 <a:ea typeface="Calibri" pitchFamily="34" charset="-122"/>
                 <a:cs typeface="Calibri" pitchFamily="34" charset="-120"/>
               </a:rPr>
-              <a:t>AI proposes the material family and process route with a confidence score — you stay in control.</a:t>
+              <a:t>AI proposes the material family and process route with a confidence score — we stay in control.</a:t>
             </a:r>
             <a:endParaRPr lang="en-US" sz="1000" dirty="0"/>
           </a:p>
@@ -48724,7 +48724,7 @@
                 <a:ea typeface="Calibri" pitchFamily="34" charset="-122"/>
                 <a:cs typeface="Calibri" pitchFamily="34" charset="-120"/>
               </a:rPr>
-              <a:t>Suggested material family and process route, each with an explicit confidence score you can accept or override.</a:t>
+              <a:t>Suggested material family and process route, each with an explicit confidence score we can accept or override.</a:t>
             </a:r>
             <a:endParaRPr lang="en-US" sz="1000" dirty="0"/>
           </a:p>

</xml_diff>

<commit_message>
Executive Briefing: add custom hero graphic to the title slide
Add an on-brand, custom-designed hero visual to the navy title slide — an
isometric machined part (glowing B-rep edges, holes) with AI nodes radiating
in and a subtle cost curve, echoing the CAD-to-Cost story. Rendered from
hand-authored SVG (no stock imagery, no licensing), embedded in the pptx.

Kept to the title slide by design: the other slides are light-themed and
content-dense, where a neon visual would clash or clutter.

Co-Authored-By: Claude Opus 4.8 <noreply@anthropic.com>
Claude-Session: https://claude.ai/code/session_0142L4rKS2AV8rxQTDWMs7dy
</commit_message>
<xml_diff>
--- a/CostVision-Platform-Executive-Briefing.pptx
+++ b/CostVision-Platform-Executive-Briefing.pptx
@@ -4411,9 +4411,33 @@
           <a:ln/>
         </p:spPr>
       </p:sp>
-      <p:sp>
-        <p:nvSpPr>
-          <p:cNvPr id="6" name="Shape 4"/>
+      <p:pic>
+        <p:nvPicPr>
+          <p:cNvPr id="6" name="Image 0" descr="/tmp/claude-0/-home-user-leamington-marathi/8bf32d1a-7485-5bd6-9947-7843ee6c5644/scratchpad/art/hero.png">    </p:cNvPr>
+          <p:cNvPicPr>
+            <a:picLocks noChangeAspect="1"/>
+          </p:cNvPicPr>
+          <p:nvPr/>
+        </p:nvPicPr>
+        <p:blipFill>
+          <a:blip r:embed="rId1"/>
+          <a:stretch>
+            <a:fillRect/>
+          </a:stretch>
+        </p:blipFill>
+        <p:spPr>
+          <a:xfrm>
+            <a:off x="8458200" y="502920"/>
+            <a:ext cx="3291840" cy="3584448"/>
+          </a:xfrm>
+          <a:prstGeom prst="rect">
+            <a:avLst/>
+          </a:prstGeom>
+        </p:spPr>
+      </p:pic>
+      <p:sp>
+        <p:nvSpPr>
+          <p:cNvPr id="7" name="Shape 4"/>
           <p:cNvSpPr/>
           <p:nvPr/>
         </p:nvSpPr>
@@ -4435,7 +4459,7 @@
       </p:sp>
       <p:sp>
         <p:nvSpPr>
-          <p:cNvPr id="7" name="Text 5"/>
+          <p:cNvPr id="8" name="Text 5"/>
           <p:cNvSpPr/>
           <p:nvPr/>
         </p:nvSpPr>
@@ -4474,7 +4498,7 @@
       </p:sp>
       <p:sp>
         <p:nvSpPr>
-          <p:cNvPr id="8" name="Text 6"/>
+          <p:cNvPr id="9" name="Text 6"/>
           <p:cNvSpPr/>
           <p:nvPr/>
         </p:nvSpPr>
@@ -4513,7 +4537,7 @@
       </p:sp>
       <p:sp>
         <p:nvSpPr>
-          <p:cNvPr id="9" name="Text 7"/>
+          <p:cNvPr id="10" name="Text 7"/>
           <p:cNvSpPr/>
           <p:nvPr/>
         </p:nvSpPr>
@@ -4552,7 +4576,7 @@
       </p:sp>
       <p:sp>
         <p:nvSpPr>
-          <p:cNvPr id="10" name="Text 8"/>
+          <p:cNvPr id="11" name="Text 8"/>
           <p:cNvSpPr/>
           <p:nvPr/>
         </p:nvSpPr>
@@ -4591,7 +4615,7 @@
       </p:sp>
       <p:sp>
         <p:nvSpPr>
-          <p:cNvPr id="11" name="Text 9"/>
+          <p:cNvPr id="12" name="Text 9"/>
           <p:cNvSpPr/>
           <p:nvPr/>
         </p:nvSpPr>
@@ -4630,7 +4654,7 @@
       </p:sp>
       <p:sp>
         <p:nvSpPr>
-          <p:cNvPr id="12" name="Text 10"/>
+          <p:cNvPr id="13" name="Text 10"/>
           <p:cNvSpPr/>
           <p:nvPr/>
         </p:nvSpPr>
@@ -4692,7 +4716,7 @@
       </p:sp>
       <p:sp>
         <p:nvSpPr>
-          <p:cNvPr id="13" name="Shape 11"/>
+          <p:cNvPr id="14" name="Shape 11"/>
           <p:cNvSpPr/>
           <p:nvPr/>
         </p:nvSpPr>
@@ -4716,7 +4740,7 @@
       </p:sp>
       <p:sp>
         <p:nvSpPr>
-          <p:cNvPr id="14" name="Shape 12"/>
+          <p:cNvPr id="15" name="Shape 12"/>
           <p:cNvSpPr/>
           <p:nvPr/>
         </p:nvSpPr>
@@ -4736,7 +4760,7 @@
       </p:sp>
       <p:sp>
         <p:nvSpPr>
-          <p:cNvPr id="15" name="Text 13"/>
+          <p:cNvPr id="16" name="Text 13"/>
           <p:cNvSpPr/>
           <p:nvPr/>
         </p:nvSpPr>
@@ -4775,7 +4799,7 @@
       </p:sp>
       <p:sp>
         <p:nvSpPr>
-          <p:cNvPr id="16" name="Shape 14"/>
+          <p:cNvPr id="17" name="Shape 14"/>
           <p:cNvSpPr/>
           <p:nvPr/>
         </p:nvSpPr>
@@ -4799,7 +4823,7 @@
       </p:sp>
       <p:sp>
         <p:nvSpPr>
-          <p:cNvPr id="17" name="Shape 15"/>
+          <p:cNvPr id="18" name="Shape 15"/>
           <p:cNvSpPr/>
           <p:nvPr/>
         </p:nvSpPr>
@@ -4819,7 +4843,7 @@
       </p:sp>
       <p:sp>
         <p:nvSpPr>
-          <p:cNvPr id="18" name="Text 16"/>
+          <p:cNvPr id="19" name="Text 16"/>
           <p:cNvSpPr/>
           <p:nvPr/>
         </p:nvSpPr>
@@ -4858,7 +4882,7 @@
       </p:sp>
       <p:sp>
         <p:nvSpPr>
-          <p:cNvPr id="19" name="Shape 17"/>
+          <p:cNvPr id="20" name="Shape 17"/>
           <p:cNvSpPr/>
           <p:nvPr/>
         </p:nvSpPr>
@@ -4882,7 +4906,7 @@
       </p:sp>
       <p:sp>
         <p:nvSpPr>
-          <p:cNvPr id="20" name="Shape 18"/>
+          <p:cNvPr id="21" name="Shape 18"/>
           <p:cNvSpPr/>
           <p:nvPr/>
         </p:nvSpPr>
@@ -4902,7 +4926,7 @@
       </p:sp>
       <p:sp>
         <p:nvSpPr>
-          <p:cNvPr id="21" name="Text 19"/>
+          <p:cNvPr id="22" name="Text 19"/>
           <p:cNvSpPr/>
           <p:nvPr/>
         </p:nvSpPr>
@@ -4941,7 +4965,7 @@
       </p:sp>
       <p:sp>
         <p:nvSpPr>
-          <p:cNvPr id="22" name="Shape 20"/>
+          <p:cNvPr id="23" name="Shape 20"/>
           <p:cNvSpPr/>
           <p:nvPr/>
         </p:nvSpPr>
@@ -4965,7 +4989,7 @@
       </p:sp>
       <p:sp>
         <p:nvSpPr>
-          <p:cNvPr id="23" name="Shape 21"/>
+          <p:cNvPr id="24" name="Shape 21"/>
           <p:cNvSpPr/>
           <p:nvPr/>
         </p:nvSpPr>
@@ -4985,7 +5009,7 @@
       </p:sp>
       <p:sp>
         <p:nvSpPr>
-          <p:cNvPr id="24" name="Text 22"/>
+          <p:cNvPr id="25" name="Text 22"/>
           <p:cNvSpPr/>
           <p:nvPr/>
         </p:nvSpPr>
@@ -5024,7 +5048,7 @@
       </p:sp>
       <p:sp>
         <p:nvSpPr>
-          <p:cNvPr id="25" name="Text 23"/>
+          <p:cNvPr id="26" name="Text 23"/>
           <p:cNvSpPr/>
           <p:nvPr/>
         </p:nvSpPr>

</xml_diff>